<commit_message>
docs(release): publication-ready executive blueprints, vector diagrams, and delivery package
</commit_message>
<xml_diff>
--- a/presentacion/sustentacion_claro.pptx
+++ b/presentacion/sustentacion_claro.pptx
@@ -4,6 +4,9 @@
   <p:sldMasterIdLst>
     <p:sldMasterId id="2147483648" r:id="rId1"/>
   </p:sldMasterIdLst>
+  <p:notesMasterIdLst>
+    <p:notesMasterId r:id="rId13"/>
+  </p:notesMasterIdLst>
   <p:sldIdLst>
     <p:sldId id="256" r:id="rId2"/>
     <p:sldId id="257" r:id="rId3"/>
@@ -17,11 +20,8 @@
     <p:sldId id="265" r:id="rId11"/>
     <p:sldId id="266" r:id="rId12"/>
   </p:sldIdLst>
-  <p:notesMasterIdLst>
-    <p:notesMasterId r:id="rId13"/>
-  </p:notesMasterIdLst>
-  <p:sldSz cx="12191695" cy="6858000"/>
-  <p:notesSz cx="6858000" cy="12191695"/>
+  <p:sldSz cx="12192000" cy="6858000"/>
+  <p:notesSz cx="6858000" cy="12192000"/>
   <p:defaultTextStyle>
     <a:lvl1pPr marL="0" algn="l" defTabSz="914400" rtl="0" eaLnBrk="1" latinLnBrk="0" hangingPunct="1">
       <a:defRPr sz="1800" kern="1200">
@@ -114,13 +114,20 @@
       </a:defRPr>
     </a:lvl9pPr>
   </p:defaultTextStyle>
+  <p:extLst>
+    <p:ext uri="{EFAFB233-063F-42B5-8137-9DF3F51BA10A}">
+      <p15:sldGuideLst xmlns:p15="http://schemas.microsoft.com/office/powerpoint/2012/main"/>
+    </p:ext>
+  </p:extLst>
 </p:presentation>
 </file>
 
 <file path=ppt/charts/chart1.xml><?xml version="1.0" encoding="utf-8"?>
-<c:chartSpace xmlns:c="http://schemas.openxmlformats.org/drawingml/2006/chart" xmlns:a="http://schemas.openxmlformats.org/drawingml/2006/main" xmlns:r="http://schemas.openxmlformats.org/officeDocument/2006/relationships">
+<c:chartSpace xmlns:c="http://schemas.openxmlformats.org/drawingml/2006/chart" xmlns:a="http://schemas.openxmlformats.org/drawingml/2006/main" xmlns:r="http://schemas.openxmlformats.org/officeDocument/2006/relationships" xmlns:c16r2="http://schemas.microsoft.com/office/drawing/2015/06/chart">
   <c:date1904 val="0"/>
+  <c:lang val="es-MX"/>
   <c:roundedCorners val="1"/>
+  <c:style val="2"/>
   <c:chart>
     <c:autoTitleDeleted val="1"/>
     <c:plotArea>
@@ -163,6 +170,11 @@
               </a:solidFill>
               <a:effectLst/>
             </c:spPr>
+            <c:extLst>
+              <c:ext xmlns:c16="http://schemas.microsoft.com/office/drawing/2014/chart" uri="{C3380CC4-5D6E-409C-BE32-E72D297353CC}">
+                <c16:uniqueId val="{00000001-43C5-4BFE-81AE-793863028F91}"/>
+              </c:ext>
+            </c:extLst>
           </c:dPt>
           <c:dPt>
             <c:idx val="1"/>
@@ -173,81 +185,12 @@
               </a:solidFill>
               <a:effectLst/>
             </c:spPr>
+            <c:extLst>
+              <c:ext xmlns:c16="http://schemas.microsoft.com/office/drawing/2014/chart" uri="{C3380CC4-5D6E-409C-BE32-E72D297353CC}">
+                <c16:uniqueId val="{00000003-43C5-4BFE-81AE-793863028F91}"/>
+              </c:ext>
+            </c:extLst>
           </c:dPt>
-          <c:dLbls>
-            <c:dLbl>
-              <c:idx val="0"/>
-              <c:numFmt formatCode="#,##0" sourceLinked="0"/>
-              <c:spPr/>
-              <c:txPr>
-                <a:bodyPr/>
-                <a:lstStyle/>
-                <a:p>
-                  <a:pPr>
-                    <a:defRPr sz="1200" b="0" i="0" u="none" strike="noStrike">
-                      <a:solidFill>
-                        <a:srgbClr val="000000"/>
-                      </a:solidFill>
-                      <a:latin typeface="Arial"/>
-                    </a:defRPr>
-                  </a:pPr>
-                </a:p>
-              </c:txPr>
-              <c:showLegendKey val="0"/>
-              <c:showVal val="0"/>
-              <c:showCatName val="0"/>
-              <c:showSerName val="0"/>
-              <c:showPercent val="0"/>
-              <c:showBubbleSize val="0"/>
-            </c:dLbl>
-            <c:dLbl>
-              <c:idx val="1"/>
-              <c:numFmt formatCode="#,##0" sourceLinked="0"/>
-              <c:spPr/>
-              <c:txPr>
-                <a:bodyPr/>
-                <a:lstStyle/>
-                <a:p>
-                  <a:pPr>
-                    <a:defRPr sz="1200" b="0" i="0" u="none" strike="noStrike">
-                      <a:solidFill>
-                        <a:srgbClr val="000000"/>
-                      </a:solidFill>
-                      <a:latin typeface="Arial"/>
-                    </a:defRPr>
-                  </a:pPr>
-                </a:p>
-              </c:txPr>
-              <c:showLegendKey val="0"/>
-              <c:showVal val="0"/>
-              <c:showCatName val="0"/>
-              <c:showSerName val="0"/>
-              <c:showPercent val="0"/>
-              <c:showBubbleSize val="0"/>
-            </c:dLbl>
-            <c:numFmt formatCode="#,##0" sourceLinked="0"/>
-            <c:txPr>
-              <a:bodyPr/>
-              <a:lstStyle/>
-              <a:p>
-                <a:pPr>
-                  <a:defRPr sz="1800" b="0" i="0" u="none" strike="noStrike">
-                    <a:solidFill>
-                      <a:srgbClr val="000000"/>
-                    </a:solidFill>
-                    <a:latin typeface="Arial"/>
-                  </a:defRPr>
-                </a:pPr>
-              </a:p>
-            </c:txPr>
-            <c:showLegendKey val="0"/>
-            <c:showVal val="0"/>
-            <c:showCatName val="1"/>
-            <c:showSerName val="0"/>
-            <c:showPercent val="1"/>
-            <c:showBubbleSize val="0"/>
-            <c:showLeaderLines val="0"/>
-          </c:dLbls>
           <c:cat>
             <c:strRef>
               <c:f>Sheet1!$A$2:$A$3</c:f>
@@ -266,6 +209,7 @@
             <c:numRef>
               <c:f>Sheet1!$B$2:$B$3</c:f>
               <c:numCache>
+                <c:formatCode>General</c:formatCode>
                 <c:ptCount val="2"/>
                 <c:pt idx="0">
                   <c:v>52</c:v>
@@ -276,7 +220,21 @@
               </c:numCache>
             </c:numRef>
           </c:val>
+          <c:extLst>
+            <c:ext xmlns:c16="http://schemas.microsoft.com/office/drawing/2014/chart" uri="{C3380CC4-5D6E-409C-BE32-E72D297353CC}">
+              <c16:uniqueId val="{00000004-43C5-4BFE-81AE-793863028F91}"/>
+            </c:ext>
+          </c:extLst>
         </c:ser>
+        <c:dLbls>
+          <c:showLegendKey val="0"/>
+          <c:showVal val="0"/>
+          <c:showCatName val="0"/>
+          <c:showSerName val="0"/>
+          <c:showPercent val="0"/>
+          <c:showBubbleSize val="0"/>
+          <c:showLeaderLines val="0"/>
+        </c:dLbls>
         <c:firstSliceAng val="270"/>
         <c:holeSize val="55"/>
       </c:doughnutChart>
@@ -290,6 +248,7 @@
     </c:plotArea>
     <c:plotVisOnly val="1"/>
     <c:dispBlanksAs val="span"/>
+    <c:showDLblsOverMax val="1"/>
   </c:chart>
   <c:spPr>
     <a:noFill/>
@@ -326,234 +285,10 @@
           <a:chExt cx="0" cy="0"/>
         </a:xfrm>
       </p:grpSpPr>
-      <p:sp>
-        <p:nvSpPr>
-          <p:cNvPr id="2" name="Header Placeholder 1"/>
-          <p:cNvSpPr>
-            <a:spLocks noGrp="1"/>
-          </p:cNvSpPr>
-          <p:nvPr>
-            <p:ph type="hdr" sz="quarter"/>
-          </p:nvPr>
-        </p:nvSpPr>
-        <p:spPr>
-          <a:xfrm>
-            <a:off x="0" y="0"/>
-            <a:ext cx="2971800" cy="458788"/>
-          </a:xfrm>
-          <a:prstGeom prst="rect">
-            <a:avLst/>
-          </a:prstGeom>
-        </p:spPr>
-        <p:txBody>
-          <a:bodyPr vert="horz" lIns="91440" tIns="45720" rIns="91440" bIns="45720" rtlCol="0"/>
-          <a:lstStyle>
-            <a:lvl1pPr algn="l">
-              <a:defRPr sz="1200"/>
-            </a:lvl1pPr>
-          </a:lstStyle>
-          <a:p>
-            <a:endParaRPr lang="en-US"/>
-          </a:p>
-        </p:txBody>
-      </p:sp>
-      <p:sp>
-        <p:nvSpPr>
-          <p:cNvPr id="3" name="Date Placeholder 2"/>
-          <p:cNvSpPr>
-            <a:spLocks noGrp="1"/>
-          </p:cNvSpPr>
-          <p:nvPr>
-            <p:ph type="dt" idx="1"/>
-          </p:nvPr>
-        </p:nvSpPr>
-        <p:spPr>
-          <a:xfrm>
-            <a:off x="3884613" y="0"/>
-            <a:ext cx="2971800" cy="458788"/>
-          </a:xfrm>
-          <a:prstGeom prst="rect">
-            <a:avLst/>
-          </a:prstGeom>
-        </p:spPr>
-        <p:txBody>
-          <a:bodyPr vert="horz" lIns="91440" tIns="45720" rIns="91440" bIns="45720" rtlCol="0"/>
-          <a:lstStyle>
-            <a:lvl1pPr algn="r">
-              <a:defRPr sz="1200"/>
-            </a:lvl1pPr>
-          </a:lstStyle>
-          <a:p>
-            <a:fld id="{5282F153-3F37-0F45-9E97-73ACFA13230C}" type="datetimeFigureOut">
-              <a:rPr lang="en-US"/>
-              <a:t>7/23/19</a:t>
-            </a:fld>
-            <a:endParaRPr lang="en-US"/>
-          </a:p>
-        </p:txBody>
-      </p:sp>
-      <p:sp>
-        <p:nvSpPr>
-          <p:cNvPr id="4" name="Slide Image Placeholder 3"/>
-          <p:cNvSpPr>
-            <a:spLocks noGrp="1" noRot="1" noChangeAspect="1"/>
-          </p:cNvSpPr>
-          <p:nvPr>
-            <p:ph type="sldImg" idx="2"/>
-          </p:nvPr>
-        </p:nvSpPr>
-        <p:spPr>
-          <a:xfrm>
-            <a:off x="685800" y="1143000"/>
-            <a:ext cx="5486400" cy="3086100"/>
-          </a:xfrm>
-          <a:prstGeom prst="rect">
-            <a:avLst/>
-          </a:prstGeom>
-          <a:noFill/>
-          <a:ln w="12700">
-            <a:solidFill>
-              <a:prstClr val="black"/>
-            </a:solidFill>
-          </a:ln>
-        </p:spPr>
-        <p:txBody>
-          <a:bodyPr vert="horz" lIns="91440" tIns="45720" rIns="91440" bIns="45720" rtlCol="0" anchor="ctr"/>
-          <a:lstStyle/>
-          <a:p>
-            <a:endParaRPr lang="en-US"/>
-          </a:p>
-        </p:txBody>
-      </p:sp>
-      <p:sp>
-        <p:nvSpPr>
-          <p:cNvPr id="5" name="Notes Placeholder 4"/>
-          <p:cNvSpPr>
-            <a:spLocks noGrp="1"/>
-          </p:cNvSpPr>
-          <p:nvPr>
-            <p:ph type="body" sz="quarter" idx="3"/>
-          </p:nvPr>
-        </p:nvSpPr>
-        <p:spPr>
-          <a:xfrm>
-            <a:off x="685800" y="4400550"/>
-            <a:ext cx="5486400" cy="3600450"/>
-          </a:xfrm>
-          <a:prstGeom prst="rect">
-            <a:avLst/>
-          </a:prstGeom>
-        </p:spPr>
-        <p:txBody>
-          <a:bodyPr vert="horz" lIns="91440" tIns="45720" rIns="91440" bIns="45720" rtlCol="0"/>
-          <a:lstStyle/>
-          <a:p>
-            <a:pPr lvl="0"/>
-            <a:r>
-              <a:rPr lang="en-US"/>
-              <a:t>Click to edit Master text styles</a:t>
-            </a:r>
-          </a:p>
-          <a:p>
-            <a:pPr lvl="1"/>
-            <a:r>
-              <a:rPr lang="en-US"/>
-              <a:t>Second level</a:t>
-            </a:r>
-          </a:p>
-          <a:p>
-            <a:pPr lvl="2"/>
-            <a:r>
-              <a:rPr lang="en-US"/>
-              <a:t>Third level</a:t>
-            </a:r>
-          </a:p>
-          <a:p>
-            <a:pPr lvl="3"/>
-            <a:r>
-              <a:rPr lang="en-US"/>
-              <a:t>Fourth level</a:t>
-            </a:r>
-          </a:p>
-          <a:p>
-            <a:pPr lvl="4"/>
-            <a:r>
-              <a:rPr lang="en-US"/>
-              <a:t>Fifth level</a:t>
-            </a:r>
-          </a:p>
-        </p:txBody>
-      </p:sp>
-      <p:sp>
-        <p:nvSpPr>
-          <p:cNvPr id="6" name="Footer Placeholder 5"/>
-          <p:cNvSpPr>
-            <a:spLocks noGrp="1"/>
-          </p:cNvSpPr>
-          <p:nvPr>
-            <p:ph type="ftr" sz="quarter" idx="4"/>
-          </p:nvPr>
-        </p:nvSpPr>
-        <p:spPr>
-          <a:xfrm>
-            <a:off x="0" y="8685213"/>
-            <a:ext cx="2971800" cy="458787"/>
-          </a:xfrm>
-          <a:prstGeom prst="rect">
-            <a:avLst/>
-          </a:prstGeom>
-        </p:spPr>
-        <p:txBody>
-          <a:bodyPr vert="horz" lIns="91440" tIns="45720" rIns="91440" bIns="45720" rtlCol="0" anchor="b"/>
-          <a:lstStyle>
-            <a:lvl1pPr algn="l">
-              <a:defRPr sz="1200"/>
-            </a:lvl1pPr>
-          </a:lstStyle>
-          <a:p>
-            <a:endParaRPr lang="en-US"/>
-          </a:p>
-        </p:txBody>
-      </p:sp>
-      <p:sp>
-        <p:nvSpPr>
-          <p:cNvPr id="7" name="Slide Number Placeholder 6"/>
-          <p:cNvSpPr>
-            <a:spLocks noGrp="1"/>
-          </p:cNvSpPr>
-          <p:nvPr>
-            <p:ph type="sldNum" sz="quarter" idx="5"/>
-          </p:nvPr>
-        </p:nvSpPr>
-        <p:spPr>
-          <a:xfrm>
-            <a:off x="3884613" y="8685213"/>
-            <a:ext cx="2971800" cy="458787"/>
-          </a:xfrm>
-          <a:prstGeom prst="rect">
-            <a:avLst/>
-          </a:prstGeom>
-        </p:spPr>
-        <p:txBody>
-          <a:bodyPr vert="horz" lIns="91440" tIns="45720" rIns="91440" bIns="45720" rtlCol="0" anchor="b"/>
-          <a:lstStyle>
-            <a:lvl1pPr algn="r">
-              <a:defRPr sz="1200"/>
-            </a:lvl1pPr>
-          </a:lstStyle>
-          <a:p>
-            <a:fld id="{CE5E9CC1-C706-0F49-92D6-E571CC5EEA8F}" type="slidenum">
-              <a:rPr lang="en-US"/>
-              <a:t>‹#›</a:t>
-            </a:fld>
-            <a:endParaRPr lang="en-US"/>
-          </a:p>
-        </p:txBody>
-      </p:sp>
     </p:spTree>
     <p:extLst>
       <p:ext uri="{BB962C8B-B14F-4D97-AF65-F5344CB8AC3E}">
-        <p14:creationId xmlns:p14="http://schemas.microsoft.com/office/powerpoint/2010/main" val="1024086991"/>
+        <p14:creationId xmlns:p14="http://schemas.microsoft.com/office/powerpoint/2010/main" val="616297033"/>
       </p:ext>
     </p:extLst>
   </p:cSld>
@@ -704,7 +439,6 @@
 [Sources]
 - Artefactos del repositorio entregado: metricas_modelos.json, resumen_voz_cliente.json, shap_drivers.json, matriz_accionables_roi.md, databricks_blueprint.md.</a:t>
             </a:r>
-            <a:endParaRPr lang="en-US" dirty="0"/>
           </a:p>
         </p:txBody>
       </p:sp>
@@ -795,7 +529,6 @@
 [Sources]
 - Artefactos del repositorio entregado: metricas_modelos.json, resumen_voz_cliente.json, shap_drivers.json, matriz_accionables_roi.md, databricks_blueprint.md.</a:t>
             </a:r>
-            <a:endParaRPr lang="en-US" dirty="0"/>
           </a:p>
         </p:txBody>
       </p:sp>
@@ -886,7 +619,6 @@
 [Sources]
 - Artefactos del repositorio entregado: metricas_modelos.json, resumen_voz_cliente.json, shap_drivers.json, matriz_accionables_roi.md, databricks_blueprint.md.</a:t>
             </a:r>
-            <a:endParaRPr lang="en-US" dirty="0"/>
           </a:p>
         </p:txBody>
       </p:sp>
@@ -977,7 +709,6 @@
 [Sources]
 - Artefactos del repositorio entregado: metricas_modelos.json, resumen_voz_cliente.json, shap_drivers.json, matriz_accionables_roi.md, databricks_blueprint.md.</a:t>
             </a:r>
-            <a:endParaRPr lang="en-US" dirty="0"/>
           </a:p>
         </p:txBody>
       </p:sp>
@@ -1068,7 +799,6 @@
 [Sources]
 - Artefactos del repositorio entregado: metricas_modelos.json, resumen_voz_cliente.json, shap_drivers.json, matriz_accionables_roi.md, databricks_blueprint.md.</a:t>
             </a:r>
-            <a:endParaRPr lang="en-US" dirty="0"/>
           </a:p>
         </p:txBody>
       </p:sp>
@@ -1159,7 +889,6 @@
 [Sources]
 - Artefactos del repositorio entregado: metricas_modelos.json, resumen_voz_cliente.json, shap_drivers.json, matriz_accionables_roi.md, databricks_blueprint.md.</a:t>
             </a:r>
-            <a:endParaRPr lang="en-US" dirty="0"/>
           </a:p>
         </p:txBody>
       </p:sp>
@@ -1250,7 +979,6 @@
 [Sources]
 - Artefactos del repositorio entregado: metricas_modelos.json, resumen_voz_cliente.json, shap_drivers.json, matriz_accionables_roi.md, databricks_blueprint.md.</a:t>
             </a:r>
-            <a:endParaRPr lang="en-US" dirty="0"/>
           </a:p>
         </p:txBody>
       </p:sp>
@@ -1341,7 +1069,6 @@
 [Sources]
 - Artefactos del repositorio entregado: metricas_modelos.json, resumen_voz_cliente.json, shap_drivers.json, matriz_accionables_roi.md, databricks_blueprint.md.</a:t>
             </a:r>
-            <a:endParaRPr lang="en-US" dirty="0"/>
           </a:p>
         </p:txBody>
       </p:sp>
@@ -1432,7 +1159,6 @@
 [Sources]
 - Artefactos del repositorio entregado: metricas_modelos.json, resumen_voz_cliente.json, shap_drivers.json, matriz_accionables_roi.md, databricks_blueprint.md.</a:t>
             </a:r>
-            <a:endParaRPr lang="en-US" dirty="0"/>
           </a:p>
         </p:txBody>
       </p:sp>
@@ -1523,7 +1249,6 @@
 [Sources]
 - Artefactos del repositorio entregado: metricas_modelos.json, resumen_voz_cliente.json, shap_drivers.json, matriz_accionables_roi.md, databricks_blueprint.md.</a:t>
             </a:r>
-            <a:endParaRPr lang="en-US" dirty="0"/>
           </a:p>
         </p:txBody>
       </p:sp>
@@ -1614,7 +1339,6 @@
 [Sources]
 - Artefactos del repositorio entregado: metricas_modelos.json, resumen_voz_cliente.json, shap_drivers.json, matriz_accionables_roi.md, databricks_blueprint.md.</a:t>
             </a:r>
-            <a:endParaRPr lang="en-US" dirty="0"/>
           </a:p>
         </p:txBody>
       </p:sp>
@@ -1692,6 +1416,7 @@
         <a:solidFill>
           <a:srgbClr val="F7F8FA"/>
         </a:solidFill>
+        <a:effectLst/>
       </p:bgPr>
     </p:bg>
     <p:spTree>
@@ -1730,6 +1455,13 @@
             <a:prstDash val="solid"/>
           </a:ln>
         </p:spPr>
+        <p:txBody>
+          <a:bodyPr/>
+          <a:lstStyle/>
+          <a:p>
+            <a:endParaRPr lang="es-CO"/>
+          </a:p>
+        </p:txBody>
       </p:sp>
       <p:sp>
         <p:nvSpPr>
@@ -1752,7 +1484,7 @@
           <a:bodyPr wrap="square" rtlCol="0" anchor="ctr"/>
           <a:lstStyle/>
           <a:p>
-            <a:pPr indent="0" marL="0">
+            <a:pPr marL="0" indent="0">
               <a:buNone/>
             </a:pPr>
             <a:r>
@@ -1791,7 +1523,7 @@
           <a:bodyPr wrap="square" rtlCol="0" anchor="ctr"/>
           <a:lstStyle/>
           <a:p>
-            <a:pPr algn="r" indent="0" marL="0">
+            <a:pPr marL="0" indent="0" algn="r">
               <a:buNone/>
             </a:pPr>
             <a:r>
@@ -1829,7 +1561,7 @@
           </a:prstGeom>
           <a:extLst>
             <a:ext uri="{C572A759-6A51-4108-AA02-DFA0A04FC94B}">
-              <ma14:wrappingTextBoxFlag xmlns:ma14="http://schemas.microsoft.com/office/mac/drawingml/2011/main" val="0"/>
+              <ma14:wrappingTextBoxFlag xmlns:ma14="http://schemas.microsoft.com/office/mac/drawingml/2011/main" xmlns="" val="0"/>
             </a:ext>
           </a:extLst>
         </p:spPr>
@@ -1847,8 +1579,8 @@
           <a:p>
             <a:pPr algn="l"/>
             <a:fld id="{F7021451-1387-4CA6-816F-3879F97B5CBC}" type="slidenum">
-              <a:rPr b="0" lang="en-US"/>
-              <a:t>1002</a:t>
+              <a:rPr lang="en-US" b="0"/>
+              <a:t>‹Nº›</a:t>
             </a:fld>
             <a:endParaRPr lang="en-US"/>
           </a:p>
@@ -1865,6 +1597,11 @@
 <file path=ppt/slideMasters/slideMaster1.xml><?xml version="1.0" encoding="utf-8"?>
 <p:sldMaster xmlns:a="http://schemas.openxmlformats.org/drawingml/2006/main" xmlns:r="http://schemas.openxmlformats.org/officeDocument/2006/relationships" xmlns:p="http://schemas.openxmlformats.org/presentationml/2006/main">
   <p:cSld>
+    <p:bg>
+      <p:bgRef idx="1001">
+        <a:schemeClr val="bg1"/>
+      </p:bgRef>
+    </p:bg>
     <p:spTree>
       <p:nvGrpSpPr>
         <p:cNvPr id="1" name=""/>
@@ -1899,7 +1636,7 @@
           </a:prstGeom>
           <a:extLst>
             <a:ext uri="{C572A759-6A51-4108-AA02-DFA0A04FC94B}">
-              <ma14:wrappingTextBoxFlag xmlns:ma14="http://schemas.microsoft.com/office/mac/drawingml/2011/main" val="0"/>
+              <ma14:wrappingTextBoxFlag xmlns:ma14="http://schemas.microsoft.com/office/mac/drawingml/2011/main" xmlns="" val="0"/>
             </a:ext>
           </a:extLst>
         </p:spPr>
@@ -1917,8 +1654,8 @@
           <a:p>
             <a:pPr algn="l"/>
             <a:fld id="{F7021451-1387-4CA6-816F-3879F97B5CBC}" type="slidenum">
-              <a:rPr b="0" lang="en-US"/>
-              <a:t>null</a:t>
+              <a:rPr lang="en-US" b="0"/>
+              <a:t>‹Nº›</a:t>
             </a:fld>
             <a:endParaRPr lang="en-US"/>
           </a:p>
@@ -2191,8 +1928,9 @@
     <p:bg>
       <p:bgPr>
         <a:solidFill>
-          <a:srgbClr val="081426"/>
+          <a:srgbClr val="FFFFFF"/>
         </a:solidFill>
+        <a:effectLst/>
       </p:bgPr>
     </p:bg>
     <p:spTree>
@@ -2233,6 +1971,13 @@
             <a:prstDash val="solid"/>
           </a:ln>
         </p:spPr>
+        <p:txBody>
+          <a:bodyPr/>
+          <a:lstStyle/>
+          <a:p>
+            <a:endParaRPr/>
+          </a:p>
+        </p:txBody>
       </p:sp>
       <p:sp>
         <p:nvSpPr>
@@ -2255,7 +2000,7 @@
           <a:bodyPr wrap="square" lIns="0" tIns="0" rIns="0" bIns="0" rtlCol="0" anchor="ctr"/>
           <a:lstStyle/>
           <a:p>
-            <a:pPr indent="0" marL="0">
+            <a:pPr marL="0" indent="0">
               <a:buNone/>
             </a:pPr>
             <a:r>
@@ -2296,13 +2041,13 @@
           </a:bodyPr>
           <a:lstStyle/>
           <a:p>
-            <a:pPr indent="0" marL="0">
+            <a:pPr marL="0" indent="0">
               <a:buNone/>
             </a:pPr>
             <a:r>
               <a:rPr lang="en-US" sz="3100" b="1" dirty="0">
                 <a:solidFill>
-                  <a:srgbClr val="FFFFFF"/>
+                  <a:srgbClr val="0F172A"/>
                 </a:solidFill>
                 <a:latin typeface="Aptos Display" pitchFamily="34" charset="0"/>
                 <a:ea typeface="Aptos Display" pitchFamily="34" charset="-122"/>
@@ -2313,13 +2058,13 @@
             <a:endParaRPr lang="en-US" sz="3100" dirty="0"/>
           </a:p>
           <a:p>
-            <a:pPr indent="0" marL="0">
+            <a:pPr marL="0" indent="0">
               <a:buNone/>
             </a:pPr>
             <a:r>
               <a:rPr lang="en-US" sz="3100" b="1" dirty="0">
                 <a:solidFill>
-                  <a:srgbClr val="FFFFFF"/>
+                  <a:srgbClr val="0F172A"/>
                 </a:solidFill>
                 <a:latin typeface="Aptos Display" pitchFamily="34" charset="0"/>
                 <a:ea typeface="Aptos Display" pitchFamily="34" charset="-122"/>
@@ -2330,13 +2075,13 @@
             <a:endParaRPr lang="en-US" sz="3100" dirty="0"/>
           </a:p>
           <a:p>
-            <a:pPr indent="0" marL="0">
+            <a:pPr marL="0" indent="0">
               <a:buNone/>
             </a:pPr>
             <a:r>
               <a:rPr lang="en-US" sz="3100" b="1" dirty="0">
                 <a:solidFill>
-                  <a:srgbClr val="FFFFFF"/>
+                  <a:srgbClr val="0F172A"/>
                 </a:solidFill>
                 <a:latin typeface="Aptos Display" pitchFamily="34" charset="0"/>
                 <a:ea typeface="Aptos Display" pitchFamily="34" charset="-122"/>
@@ -2369,13 +2114,13 @@
           <a:bodyPr wrap="square" lIns="0" tIns="0" rIns="0" bIns="0" rtlCol="0" anchor="ctr"/>
           <a:lstStyle/>
           <a:p>
-            <a:pPr indent="0" marL="0">
+            <a:pPr marL="0" indent="0">
               <a:buNone/>
             </a:pPr>
             <a:r>
               <a:rPr lang="en-US" sz="1250" dirty="0">
                 <a:solidFill>
-                  <a:srgbClr val="DDE3EA"/>
+                  <a:srgbClr val="475569"/>
                 </a:solidFill>
                 <a:latin typeface="Aptos" pitchFamily="34" charset="0"/>
                 <a:ea typeface="Aptos" pitchFamily="34" charset="-122"/>
@@ -2414,7 +2159,7 @@
           <a:bodyPr wrap="square" lIns="254" tIns="254" rIns="254" bIns="254" rtlCol="0" anchor="ctr"/>
           <a:lstStyle/>
           <a:p>
-            <a:pPr algn="ctr" indent="0" marL="0">
+            <a:pPr marL="0" indent="0" algn="ctr">
               <a:buNone/>
             </a:pPr>
             <a:r>
@@ -2447,11 +2192,11 @@
             <a:avLst/>
           </a:prstGeom>
           <a:solidFill>
-            <a:srgbClr val="243147"/>
+            <a:srgbClr val="F1F5F9"/>
           </a:solidFill>
           <a:ln>
             <a:solidFill>
-              <a:srgbClr val="243147"/>
+              <a:srgbClr val="CBD5E1"/>
             </a:solidFill>
           </a:ln>
         </p:spPr>
@@ -2459,19 +2204,19 @@
           <a:bodyPr wrap="square" lIns="254" tIns="254" rIns="254" bIns="254" rtlCol="0" anchor="ctr"/>
           <a:lstStyle/>
           <a:p>
-            <a:pPr algn="ctr" indent="0" marL="0">
+            <a:pPr marL="0" indent="0" algn="ctr">
               <a:buNone/>
             </a:pPr>
             <a:r>
               <a:rPr lang="en-US" sz="850" b="1" dirty="0">
                 <a:solidFill>
-                  <a:srgbClr val="FFFFFF"/>
-                </a:solidFill>
-                <a:latin typeface="Aptos" pitchFamily="34" charset="0"/>
-                <a:ea typeface="Aptos" pitchFamily="34" charset="-122"/>
-                <a:cs typeface="Aptos" pitchFamily="34" charset="-120"/>
-              </a:rPr>
-              <a:t>21/21 tests PASS</a:t>
+                  <a:srgbClr val="0F172A"/>
+                </a:solidFill>
+                <a:latin typeface="Aptos" pitchFamily="34" charset="0"/>
+                <a:ea typeface="Aptos" pitchFamily="34" charset="-122"/>
+                <a:cs typeface="Aptos" pitchFamily="34" charset="-120"/>
+              </a:rPr>
+              <a:t>23/23 tests PASS</a:t>
             </a:r>
             <a:endParaRPr lang="en-US" sz="850" dirty="0"/>
           </a:p>
@@ -2492,11 +2237,11 @@
             <a:avLst/>
           </a:prstGeom>
           <a:solidFill>
-            <a:srgbClr val="243147"/>
+            <a:srgbClr val="F1F5F9"/>
           </a:solidFill>
           <a:ln>
             <a:solidFill>
-              <a:srgbClr val="243147"/>
+              <a:srgbClr val="CBD5E1"/>
             </a:solidFill>
           </a:ln>
         </p:spPr>
@@ -2504,19 +2249,19 @@
           <a:bodyPr wrap="square" lIns="254" tIns="254" rIns="254" bIns="254" rtlCol="0" anchor="ctr"/>
           <a:lstStyle/>
           <a:p>
-            <a:pPr algn="ctr" indent="0" marL="0">
+            <a:pPr marL="0" indent="0" algn="ctr">
               <a:buNone/>
             </a:pPr>
             <a:r>
               <a:rPr lang="en-US" sz="850" b="1" dirty="0">
                 <a:solidFill>
-                  <a:srgbClr val="FFFFFF"/>
-                </a:solidFill>
-                <a:latin typeface="Aptos" pitchFamily="34" charset="0"/>
-                <a:ea typeface="Aptos" pitchFamily="34" charset="-122"/>
-                <a:cs typeface="Aptos" pitchFamily="34" charset="-120"/>
-              </a:rPr>
-              <a:t>GitHub público</a:t>
+                  <a:srgbClr val="0F172A"/>
+                </a:solidFill>
+                <a:latin typeface="Aptos" pitchFamily="34" charset="0"/>
+                <a:ea typeface="Aptos" pitchFamily="34" charset="-122"/>
+                <a:cs typeface="Aptos" pitchFamily="34" charset="-120"/>
+              </a:rPr>
+              <a:t>Repositorio GitHub</a:t>
             </a:r>
             <a:endParaRPr lang="en-US" sz="850" dirty="0"/>
           </a:p>
@@ -2530,8 +2275,8 @@
         </p:nvSpPr>
         <p:spPr>
           <a:xfrm>
-            <a:off x="713232" y="5394960"/>
-            <a:ext cx="5577840" cy="548640"/>
+            <a:off x="713232" y="4650000"/>
+            <a:ext cx="6800000" cy="1600000"/>
           </a:xfrm>
           <a:prstGeom prst="rect">
             <a:avLst/>
@@ -2543,55 +2288,131 @@
           <a:bodyPr wrap="square" lIns="0" tIns="0" rIns="0" bIns="0" rtlCol="0" anchor="ctr"/>
           <a:lstStyle/>
           <a:p>
-            <a:pPr indent="0" marL="0">
-              <a:buNone/>
-            </a:pPr>
-            <a:r>
-              <a:rPr lang="en-US" sz="850" dirty="0">
-                <a:solidFill>
-                  <a:srgbClr val="B9C2CF"/>
-                </a:solidFill>
-                <a:latin typeface="Aptos" pitchFamily="34" charset="0"/>
-                <a:ea typeface="Aptos" pitchFamily="34" charset="-122"/>
-                <a:cs typeface="Aptos" pitchFamily="34" charset="-120"/>
-              </a:rPr>
-              <a:t>Candidato: Neydher Antonio Martin Ramos</a:t>
+            <a:pPr marL="0" indent="0">
+              <a:spcAft>
+                <a:spcPts val="250"/>
+              </a:spcAft>
+              <a:buNone/>
+            </a:pPr>
+            <a:r>
+              <a:rPr sz="850" b="1">
+                <a:solidFill>
+                  <a:srgbClr val="0F172A"/>
+                </a:solidFill>
+                <a:latin typeface="Aptos"/>
+              </a:rPr>
+              <a:t>Orquestación:</a:t>
+            </a:r>
+            <a:r>
+              <a:rPr sz="850" b="0">
+                <a:solidFill>
+                  <a:srgbClr val="475569"/>
+                </a:solidFill>
+                <a:latin typeface="Aptos"/>
+              </a:rPr>
+              <a:t> Neydher Antonio Martin Ramos (Lead AI Orchestrator &amp; HITL)</a:t>
             </a:r>
             <a:endParaRPr lang="en-US" sz="850" dirty="0"/>
           </a:p>
           <a:p>
-            <a:pPr indent="0" marL="0">
-              <a:buNone/>
-            </a:pPr>
-            <a:r>
-              <a:rPr lang="en-US" sz="850" dirty="0">
-                <a:solidFill>
-                  <a:srgbClr val="B9C2CF"/>
-                </a:solidFill>
-                <a:latin typeface="Aptos" pitchFamily="34" charset="0"/>
-                <a:ea typeface="Aptos" pitchFamily="34" charset="-122"/>
-                <a:cs typeface="Aptos" pitchFamily="34" charset="-120"/>
-              </a:rPr>
-              <a:t>Evaluador: Rafael José Del Castillo Pavajeau</a:t>
-            </a:r>
-            <a:endParaRPr lang="en-US" sz="850" dirty="0"/>
-          </a:p>
-          <a:p>
-            <a:pPr indent="0" marL="0">
-              <a:buNone/>
-            </a:pPr>
-            <a:r>
-              <a:rPr lang="en-US" sz="850" dirty="0">
-                <a:solidFill>
-                  <a:srgbClr val="B9C2CF"/>
-                </a:solidFill>
-                <a:latin typeface="Aptos" pitchFamily="34" charset="0"/>
-                <a:ea typeface="Aptos" pitchFamily="34" charset="-122"/>
-                <a:cs typeface="Aptos" pitchFamily="34" charset="-120"/>
-              </a:rPr>
-              <a:t>Septiembre 2026</a:t>
-            </a:r>
-            <a:endParaRPr lang="en-US" sz="850" dirty="0"/>
+            <a:pPr>
+              <a:spcAft>
+                <a:spcPts val="250"/>
+              </a:spcAft>
+            </a:pPr>
+            <a:r>
+              <a:rPr sz="850" b="1">
+                <a:solidFill>
+                  <a:srgbClr val="0F172A"/>
+                </a:solidFill>
+                <a:latin typeface="Aptos"/>
+              </a:rPr>
+              <a:t>Evaluador:</a:t>
+            </a:r>
+            <a:r>
+              <a:rPr sz="850" b="0">
+                <a:solidFill>
+                  <a:srgbClr val="475569"/>
+                </a:solidFill>
+                <a:latin typeface="Aptos"/>
+              </a:rPr>
+              <a:t> Rafael José Del Castillo Pavajeau (Gerencia Analítica Avanzada)</a:t>
+            </a:r>
+          </a:p>
+          <a:p>
+            <a:pPr>
+              <a:spcAft>
+                <a:spcPts val="250"/>
+              </a:spcAft>
+            </a:pPr>
+            <a:r>
+              <a:rPr sz="850" b="1">
+                <a:solidFill>
+                  <a:srgbClr val="0F172A"/>
+                </a:solidFill>
+                <a:latin typeface="Aptos"/>
+              </a:rPr>
+              <a:t>Challenger Agent:</a:t>
+            </a:r>
+            <a:r>
+              <a:rPr sz="850" b="0">
+                <a:solidFill>
+                  <a:srgbClr val="475569"/>
+                </a:solidFill>
+                <a:latin typeface="Aptos"/>
+              </a:rPr>
+              <a:t> ChatGPT — GPT-5.6 Sol (OpenAI) | Auditoría de Gates y Red Teaming</a:t>
+            </a:r>
+          </a:p>
+          <a:p>
+            <a:pPr>
+              <a:spcAft>
+                <a:spcPts val="250"/>
+              </a:spcAft>
+            </a:pPr>
+            <a:r>
+              <a:rPr sz="850" b="1">
+                <a:solidFill>
+                  <a:srgbClr val="0F172A"/>
+                </a:solidFill>
+                <a:latin typeface="Aptos"/>
+              </a:rPr>
+              <a:t>Execution Agent:</a:t>
+            </a:r>
+            <a:r>
+              <a:rPr sz="850" b="0">
+                <a:solidFill>
+                  <a:srgbClr val="475569"/>
+                </a:solidFill>
+                <a:latin typeface="Aptos"/>
+              </a:rPr>
+              <a:t> Gemini Flash 3.8 (Google / Antigravity) | ML &amp; Agentic Engineering</a:t>
+            </a:r>
+          </a:p>
+          <a:p>
+            <a:pPr>
+              <a:spcAft>
+                <a:spcPts val="250"/>
+              </a:spcAft>
+            </a:pPr>
+            <a:r>
+              <a:rPr sz="850" b="1">
+                <a:solidFill>
+                  <a:srgbClr val="0F172A"/>
+                </a:solidFill>
+                <a:latin typeface="Aptos"/>
+              </a:rPr>
+              <a:t>Fecha:</a:t>
+            </a:r>
+            <a:r>
+              <a:rPr sz="850" b="0">
+                <a:solidFill>
+                  <a:srgbClr val="475569"/>
+                </a:solidFill>
+                <a:latin typeface="Aptos"/>
+              </a:rPr>
+              <a:t> Septiembre 2026</a:t>
+            </a:r>
           </a:p>
         </p:txBody>
       </p:sp>
@@ -2616,20 +2437,9 @@
           <a:bodyPr wrap="square" lIns="0" tIns="0" rIns="0" bIns="0" rtlCol="0" anchor="ctr"/>
           <a:lstStyle/>
           <a:p>
-            <a:pPr indent="0" marL="0">
-              <a:buNone/>
-            </a:pPr>
-            <a:r>
-              <a:rPr lang="en-US" sz="850" b="1" dirty="0">
-                <a:solidFill>
-                  <a:srgbClr val="D71920"/>
-                </a:solidFill>
-                <a:latin typeface="Aptos" pitchFamily="34" charset="0"/>
-                <a:ea typeface="Aptos" pitchFamily="34" charset="-122"/>
-                <a:cs typeface="Aptos" pitchFamily="34" charset="-120"/>
-              </a:rPr>
-              <a:t>Tesis</a:t>
-            </a:r>
+            <a:pPr marL="0" indent="0">
+              <a:buNone/>
+            </a:pPr>
             <a:endParaRPr lang="en-US" sz="850" dirty="0"/>
           </a:p>
         </p:txBody>
@@ -2657,20 +2467,9 @@
           </a:bodyPr>
           <a:lstStyle/>
           <a:p>
-            <a:pPr indent="0" marL="0">
-              <a:buNone/>
-            </a:pPr>
-            <a:r>
-              <a:rPr lang="en-US" sz="1250" b="1" dirty="0">
-                <a:solidFill>
-                  <a:srgbClr val="FFFFFF"/>
-                </a:solidFill>
-                <a:latin typeface="Aptos Display" pitchFamily="34" charset="0"/>
-                <a:ea typeface="Aptos Display" pitchFamily="34" charset="-122"/>
-                <a:cs typeface="Aptos Display" pitchFamily="34" charset="-120"/>
-              </a:rPr>
-              <a:t>No basta con retener al cliente que llama a cancelar. El sistema debe detectar también la fuga silenciosa y gobernar la acción correcta.</a:t>
-            </a:r>
+            <a:pPr marL="0" indent="0">
+              <a:buNone/>
+            </a:pPr>
             <a:endParaRPr lang="en-US" sz="1250" dirty="0"/>
           </a:p>
         </p:txBody>
@@ -2695,7 +2494,7 @@
           </a:prstGeom>
           <a:extLst>
             <a:ext uri="{C572A759-6A51-4108-AA02-DFA0A04FC94B}">
-              <ma14:wrappingTextBoxFlag xmlns:ma14="http://schemas.microsoft.com/office/mac/drawingml/2011/main" val="0"/>
+              <ma14:wrappingTextBoxFlag xmlns:ma14="http://schemas.microsoft.com/office/mac/drawingml/2011/main" xmlns="" val="0"/>
             </a:ext>
           </a:extLst>
         </p:spPr>
@@ -2713,10 +2512,219 @@
           <a:p>
             <a:pPr algn="l"/>
             <a:fld id="{F7021451-1387-4CA6-816F-3879F97B5CBC}" type="slidenum">
-              <a:rPr b="0" lang="en-US"/>
+              <a:rPr lang="en-US" b="0"/>
               <a:t>1</a:t>
             </a:fld>
             <a:endParaRPr lang="en-US"/>
+          </a:p>
+        </p:txBody>
+      </p:sp>
+      <p:sp>
+        <p:nvSpPr>
+          <p:cNvPr id="26" name="Rectangle 25"/>
+          <p:cNvSpPr/>
+          <p:nvPr/>
+        </p:nvSpPr>
+        <p:spPr>
+          <a:xfrm>
+            <a:off x="7500000" y="1325880"/>
+            <a:ext cx="4000000" cy="4750000"/>
+          </a:xfrm>
+          <a:prstGeom prst="rect">
+            <a:avLst/>
+          </a:prstGeom>
+          <a:solidFill>
+            <a:srgbClr val="F8FAFC"/>
+          </a:solidFill>
+          <a:ln w="12700">
+            <a:solidFill>
+              <a:srgbClr val="E2E8F0"/>
+            </a:solidFill>
+          </a:ln>
+        </p:spPr>
+        <p:style>
+          <a:lnRef idx="1">
+            <a:schemeClr val="accent1"/>
+          </a:lnRef>
+          <a:fillRef idx="3">
+            <a:schemeClr val="accent1"/>
+          </a:fillRef>
+          <a:effectRef idx="2">
+            <a:schemeClr val="accent1"/>
+          </a:effectRef>
+          <a:fontRef idx="minor">
+            <a:schemeClr val="lt1"/>
+          </a:fontRef>
+        </p:style>
+        <p:txBody>
+          <a:bodyPr wrap="square" lIns="320040" tIns="347472" rIns="320040" bIns="274320" rtlCol="0" anchor="ctr"/>
+          <a:lstStyle/>
+          <a:p>
+            <a:pPr algn="ctr">
+              <a:spcAft>
+                <a:spcPts val="1400"/>
+              </a:spcAft>
+            </a:pPr>
+            <a:r>
+              <a:rPr sz="1100" b="1">
+                <a:solidFill>
+                  <a:srgbClr val="D71920"/>
+                </a:solidFill>
+                <a:latin typeface="Aptos"/>
+              </a:rPr>
+              <a:t>TESIS ESTRATÉGICA</a:t>
+            </a:r>
+          </a:p>
+          <a:p>
+            <a:pPr>
+              <a:spcAft>
+                <a:spcPts val="1800"/>
+              </a:spcAft>
+            </a:pPr>
+            <a:r>
+              <a:rPr sz="1300" b="1">
+                <a:solidFill>
+                  <a:srgbClr val="0F172A"/>
+                </a:solidFill>
+                <a:latin typeface="Aptos"/>
+              </a:rPr>
+              <a:t>«No basta con retener al cliente que llama a cancelar. El sistema debe detectar también la fuga silenciosa y gobernar la acción correcta.»</a:t>
+            </a:r>
+          </a:p>
+          <a:p>
+            <a:pPr>
+              <a:spcAft>
+                <a:spcPts val="1200"/>
+              </a:spcAft>
+            </a:pPr>
+            <a:r>
+              <a:rPr sz="900" b="1">
+                <a:solidFill>
+                  <a:srgbClr val="64748B"/>
+                </a:solidFill>
+                <a:latin typeface="Aptos"/>
+              </a:rPr>
+              <a:t>PILARES CLAVE DE LA SOLUCIÓN</a:t>
+            </a:r>
+          </a:p>
+          <a:p>
+            <a:pPr>
+              <a:spcAft>
+                <a:spcPts val="800"/>
+              </a:spcAft>
+            </a:pPr>
+            <a:r>
+              <a:rPr sz="950" b="1">
+                <a:solidFill>
+                  <a:srgbClr val="1E293B"/>
+                </a:solidFill>
+                <a:latin typeface="Aptos"/>
+              </a:rPr>
+              <a:t>• 50% Fuga Silenciosa: </a:t>
+            </a:r>
+            <a:r>
+              <a:rPr sz="900" b="0">
+                <a:solidFill>
+                  <a:srgbClr val="64748B"/>
+                </a:solidFill>
+                <a:latin typeface="Aptos"/>
+              </a:rPr>
+              <a:t>52 de 104 cancelaciones reales nunca llamaron a manifestar intención previa.</a:t>
+            </a:r>
+          </a:p>
+          <a:p>
+            <a:pPr>
+              <a:spcAft>
+                <a:spcPts val="800"/>
+              </a:spcAft>
+            </a:pPr>
+            <a:r>
+              <a:rPr sz="950" b="1">
+                <a:solidFill>
+                  <a:srgbClr val="1E293B"/>
+                </a:solidFill>
+                <a:latin typeface="Aptos"/>
+              </a:rPr>
+              <a:t>• Lift@10 = 9.05x: </a:t>
+            </a:r>
+            <a:r>
+              <a:rPr sz="900" b="0">
+                <a:solidFill>
+                  <a:srgbClr val="64748B"/>
+                </a:solidFill>
+                <a:latin typeface="Aptos"/>
+              </a:rPr>
+              <a:t>El Modelo A concentra el riesgo 9 veces por encima del azar en el Decil 1 prioritario.</a:t>
+            </a:r>
+          </a:p>
+          <a:p>
+            <a:pPr>
+              <a:spcAft>
+                <a:spcPts val="800"/>
+              </a:spcAft>
+            </a:pPr>
+            <a:r>
+              <a:rPr sz="950" b="1">
+                <a:solidFill>
+                  <a:srgbClr val="1E293B"/>
+                </a:solidFill>
+                <a:latin typeface="Aptos"/>
+              </a:rPr>
+              <a:t>• ROI Neto +1.50x: </a:t>
+            </a:r>
+            <a:r>
+              <a:rPr sz="900" b="0">
+                <a:solidFill>
+                  <a:srgbClr val="64748B"/>
+                </a:solidFill>
+                <a:latin typeface="Aptos"/>
+              </a:rPr>
+              <a:t>Triaje selectivo en Top 500 protege $15.6M COP con $6.25M COP de inversión.</a:t>
+            </a:r>
+          </a:p>
+        </p:txBody>
+      </p:sp>
+      <p:sp>
+        <p:nvSpPr>
+          <p:cNvPr id="27" name="Rectangle 26"/>
+          <p:cNvSpPr/>
+          <p:nvPr/>
+        </p:nvSpPr>
+        <p:spPr>
+          <a:xfrm>
+            <a:off x="7500000" y="1325880"/>
+            <a:ext cx="4000000" cy="45720"/>
+          </a:xfrm>
+          <a:prstGeom prst="rect">
+            <a:avLst/>
+          </a:prstGeom>
+          <a:solidFill>
+            <a:srgbClr val="D71920"/>
+          </a:solidFill>
+          <a:ln>
+            <a:noFill/>
+          </a:ln>
+        </p:spPr>
+        <p:style>
+          <a:lnRef idx="1">
+            <a:schemeClr val="accent1"/>
+          </a:lnRef>
+          <a:fillRef idx="3">
+            <a:schemeClr val="accent1"/>
+          </a:fillRef>
+          <a:effectRef idx="2">
+            <a:schemeClr val="accent1"/>
+          </a:effectRef>
+          <a:fontRef idx="minor">
+            <a:schemeClr val="lt1"/>
+          </a:fontRef>
+        </p:style>
+        <p:txBody>
+          <a:bodyPr rtlCol="0" anchor="ctr"/>
+          <a:lstStyle/>
+          <a:p>
+            <a:pPr algn="ctr"/>
+            <a:endParaRPr/>
           </a:p>
         </p:txBody>
       </p:sp>
@@ -2772,7 +2780,7 @@
           <a:bodyPr wrap="square" lIns="254" tIns="254" rIns="254" bIns="254" rtlCol="0" anchor="ctr"/>
           <a:lstStyle/>
           <a:p>
-            <a:pPr algn="ctr" indent="0" marL="0">
+            <a:pPr marL="0" indent="0" algn="ctr">
               <a:buNone/>
             </a:pPr>
             <a:r>
@@ -2811,7 +2819,7 @@
           <a:bodyPr wrap="square" lIns="0" tIns="0" rIns="0" bIns="0" rtlCol="0" anchor="ctr"/>
           <a:lstStyle/>
           <a:p>
-            <a:pPr indent="0" marL="0">
+            <a:pPr marL="0" indent="0">
               <a:buNone/>
             </a:pPr>
             <a:r>
@@ -2852,7 +2860,7 @@
           </a:bodyPr>
           <a:lstStyle/>
           <a:p>
-            <a:pPr indent="0" marL="0">
+            <a:pPr marL="0" indent="0">
               <a:buNone/>
             </a:pPr>
             <a:r>
@@ -2893,7 +2901,7 @@
           </a:bodyPr>
           <a:lstStyle/>
           <a:p>
-            <a:pPr indent="0" marL="0">
+            <a:pPr marL="0" indent="0">
               <a:buNone/>
             </a:pPr>
             <a:r>
@@ -2934,7 +2942,7 @@
             </a:solidFill>
           </a:ln>
           <a:effectLst>
-            <a:outerShdw sx="100000" sy="100000" kx="0" ky="0" algn="bl" rotWithShape="0" blurRad="19050" dist="8890" dir="2700000">
+            <a:outerShdw blurRad="19050" dist="8890" dir="2700000" algn="bl" rotWithShape="0">
               <a:srgbClr val="000000">
                 <a:alpha val="11000"/>
               </a:srgbClr>
@@ -2945,7 +2953,7 @@
           <a:bodyPr wrap="square" lIns="0" tIns="0" rIns="0" bIns="0" rtlCol="0" anchor="ctr"/>
           <a:lstStyle/>
           <a:p>
-            <a:pPr indent="0" marL="0">
+            <a:pPr marL="0" indent="0">
               <a:buNone/>
             </a:pPr>
             <a:endParaRPr lang="en-US" dirty="0"/>
@@ -2973,7 +2981,7 @@
           <a:bodyPr wrap="square" lIns="0" tIns="0" rIns="0" bIns="0" rtlCol="0" anchor="ctr"/>
           <a:lstStyle/>
           <a:p>
-            <a:pPr indent="0" marL="0">
+            <a:pPr marL="0" indent="0">
               <a:buNone/>
             </a:pPr>
             <a:r>
@@ -3014,7 +3022,7 @@
           </a:bodyPr>
           <a:lstStyle/>
           <a:p>
-            <a:pPr indent="0" marL="0">
+            <a:pPr marL="0" indent="0">
               <a:buNone/>
             </a:pPr>
             <a:r>
@@ -3059,7 +3067,7 @@
           <a:bodyPr wrap="square" lIns="254" tIns="254" rIns="254" bIns="254" rtlCol="0" anchor="ctr"/>
           <a:lstStyle/>
           <a:p>
-            <a:pPr algn="ctr" indent="0" marL="0">
+            <a:pPr marL="0" indent="0" algn="ctr">
               <a:buNone/>
             </a:pPr>
             <a:r>
@@ -3100,7 +3108,7 @@
             </a:solidFill>
           </a:ln>
           <a:effectLst>
-            <a:outerShdw sx="100000" sy="100000" kx="0" ky="0" algn="bl" rotWithShape="0" blurRad="19050" dist="8890" dir="2700000">
+            <a:outerShdw blurRad="19050" dist="8890" dir="2700000" algn="bl" rotWithShape="0">
               <a:srgbClr val="000000">
                 <a:alpha val="11000"/>
               </a:srgbClr>
@@ -3111,7 +3119,7 @@
           <a:bodyPr wrap="square" lIns="0" tIns="0" rIns="0" bIns="0" rtlCol="0" anchor="ctr"/>
           <a:lstStyle/>
           <a:p>
-            <a:pPr indent="0" marL="0">
+            <a:pPr marL="0" indent="0">
               <a:buNone/>
             </a:pPr>
             <a:endParaRPr lang="en-US" dirty="0"/>
@@ -3139,7 +3147,7 @@
           <a:bodyPr wrap="square" lIns="0" tIns="0" rIns="0" bIns="0" rtlCol="0" anchor="ctr"/>
           <a:lstStyle/>
           <a:p>
-            <a:pPr indent="0" marL="0">
+            <a:pPr marL="0" indent="0">
               <a:buNone/>
             </a:pPr>
             <a:r>
@@ -3180,7 +3188,7 @@
           </a:bodyPr>
           <a:lstStyle/>
           <a:p>
-            <a:pPr indent="0" marL="0">
+            <a:pPr marL="0" indent="0">
               <a:buNone/>
             </a:pPr>
             <a:r>
@@ -3225,7 +3233,7 @@
           <a:bodyPr wrap="square" lIns="254" tIns="254" rIns="254" bIns="254" rtlCol="0" anchor="ctr"/>
           <a:lstStyle/>
           <a:p>
-            <a:pPr algn="ctr" indent="0" marL="0">
+            <a:pPr marL="0" indent="0" algn="ctr">
               <a:buNone/>
             </a:pPr>
             <a:r>
@@ -3266,7 +3274,7 @@
             </a:solidFill>
           </a:ln>
           <a:effectLst>
-            <a:outerShdw sx="100000" sy="100000" kx="0" ky="0" algn="bl" rotWithShape="0" blurRad="19050" dist="8890" dir="2700000">
+            <a:outerShdw blurRad="19050" dist="8890" dir="2700000" algn="bl" rotWithShape="0">
               <a:srgbClr val="000000">
                 <a:alpha val="11000"/>
               </a:srgbClr>
@@ -3277,7 +3285,7 @@
           <a:bodyPr wrap="square" lIns="0" tIns="0" rIns="0" bIns="0" rtlCol="0" anchor="ctr"/>
           <a:lstStyle/>
           <a:p>
-            <a:pPr indent="0" marL="0">
+            <a:pPr marL="0" indent="0">
               <a:buNone/>
             </a:pPr>
             <a:endParaRPr lang="en-US" dirty="0"/>
@@ -3305,7 +3313,7 @@
           <a:bodyPr wrap="square" lIns="0" tIns="0" rIns="0" bIns="0" rtlCol="0" anchor="ctr"/>
           <a:lstStyle/>
           <a:p>
-            <a:pPr indent="0" marL="0">
+            <a:pPr marL="0" indent="0">
               <a:buNone/>
             </a:pPr>
             <a:r>
@@ -3346,7 +3354,7 @@
           </a:bodyPr>
           <a:lstStyle/>
           <a:p>
-            <a:pPr indent="0" marL="0">
+            <a:pPr marL="0" indent="0">
               <a:buNone/>
             </a:pPr>
             <a:r>
@@ -3391,7 +3399,7 @@
           <a:bodyPr wrap="square" lIns="254" tIns="254" rIns="254" bIns="254" rtlCol="0" anchor="ctr"/>
           <a:lstStyle/>
           <a:p>
-            <a:pPr algn="ctr" indent="0" marL="0">
+            <a:pPr marL="0" indent="0" algn="ctr">
               <a:buNone/>
             </a:pPr>
             <a:r>
@@ -3432,7 +3440,7 @@
             </a:solidFill>
           </a:ln>
           <a:effectLst>
-            <a:outerShdw sx="100000" sy="100000" kx="0" ky="0" algn="bl" rotWithShape="0" blurRad="19050" dist="8890" dir="2700000">
+            <a:outerShdw blurRad="19050" dist="8890" dir="2700000" algn="bl" rotWithShape="0">
               <a:srgbClr val="000000">
                 <a:alpha val="11000"/>
               </a:srgbClr>
@@ -3443,7 +3451,7 @@
           <a:bodyPr wrap="square" lIns="0" tIns="0" rIns="0" bIns="0" rtlCol="0" anchor="ctr"/>
           <a:lstStyle/>
           <a:p>
-            <a:pPr indent="0" marL="0">
+            <a:pPr marL="0" indent="0">
               <a:buNone/>
             </a:pPr>
             <a:endParaRPr lang="en-US" dirty="0"/>
@@ -3471,7 +3479,7 @@
           <a:bodyPr wrap="square" lIns="0" tIns="0" rIns="0" bIns="0" rtlCol="0" anchor="ctr"/>
           <a:lstStyle/>
           <a:p>
-            <a:pPr indent="0" marL="0">
+            <a:pPr marL="0" indent="0">
               <a:buNone/>
             </a:pPr>
             <a:r>
@@ -3512,7 +3520,7 @@
           </a:bodyPr>
           <a:lstStyle/>
           <a:p>
-            <a:pPr indent="0" marL="0">
+            <a:pPr marL="0" indent="0">
               <a:buNone/>
             </a:pPr>
             <a:r>
@@ -3557,7 +3565,7 @@
           <a:bodyPr wrap="square" lIns="254" tIns="254" rIns="254" bIns="254" rtlCol="0" anchor="ctr"/>
           <a:lstStyle/>
           <a:p>
-            <a:pPr algn="ctr" indent="0" marL="0">
+            <a:pPr marL="0" indent="0" algn="ctr">
               <a:buNone/>
             </a:pPr>
             <a:r>
@@ -3598,7 +3606,7 @@
             </a:solidFill>
           </a:ln>
           <a:effectLst>
-            <a:outerShdw sx="100000" sy="100000" kx="0" ky="0" algn="bl" rotWithShape="0" blurRad="19050" dist="8890" dir="2700000">
+            <a:outerShdw blurRad="19050" dist="8890" dir="2700000" algn="bl" rotWithShape="0">
               <a:srgbClr val="000000">
                 <a:alpha val="11000"/>
               </a:srgbClr>
@@ -3609,7 +3617,7 @@
           <a:bodyPr wrap="square" lIns="0" tIns="0" rIns="0" bIns="0" rtlCol="0" anchor="ctr"/>
           <a:lstStyle/>
           <a:p>
-            <a:pPr indent="0" marL="0">
+            <a:pPr marL="0" indent="0">
               <a:buNone/>
             </a:pPr>
             <a:endParaRPr lang="en-US" dirty="0"/>
@@ -3637,7 +3645,7 @@
           <a:bodyPr wrap="square" lIns="0" tIns="0" rIns="0" bIns="0" rtlCol="0" anchor="ctr"/>
           <a:lstStyle/>
           <a:p>
-            <a:pPr indent="0" marL="0">
+            <a:pPr marL="0" indent="0">
               <a:buNone/>
             </a:pPr>
             <a:r>
@@ -3678,7 +3686,7 @@
           </a:bodyPr>
           <a:lstStyle/>
           <a:p>
-            <a:pPr indent="0" marL="0">
+            <a:pPr marL="0" indent="0">
               <a:buNone/>
             </a:pPr>
             <a:r>
@@ -3723,7 +3731,7 @@
           <a:bodyPr wrap="square" lIns="254" tIns="254" rIns="254" bIns="254" rtlCol="0" anchor="ctr"/>
           <a:lstStyle/>
           <a:p>
-            <a:pPr algn="ctr" indent="0" marL="0">
+            <a:pPr marL="0" indent="0" algn="ctr">
               <a:buNone/>
             </a:pPr>
             <a:r>
@@ -3764,7 +3772,7 @@
           </a:bodyPr>
           <a:lstStyle/>
           <a:p>
-            <a:pPr algn="ctr" indent="0" marL="0">
+            <a:pPr marL="0" indent="0" algn="ctr">
               <a:buNone/>
             </a:pPr>
             <a:r>
@@ -3784,7 +3792,7 @@
       </p:sp>
       <p:sp>
         <p:nvSpPr>
-          <p:cNvPr id="25" name="Slide Number Placeholder 0"/>
+          <p:cNvPr id="27" name="Slide Number Placeholder 0"/>
           <p:cNvSpPr>
             <a:spLocks noGrp="1"/>
           </p:cNvSpPr>
@@ -3802,7 +3810,7 @@
           </a:prstGeom>
           <a:extLst>
             <a:ext uri="{C572A759-6A51-4108-AA02-DFA0A04FC94B}">
-              <ma14:wrappingTextBoxFlag xmlns:ma14="http://schemas.microsoft.com/office/mac/drawingml/2011/main" val="0"/>
+              <ma14:wrappingTextBoxFlag xmlns:ma14="http://schemas.microsoft.com/office/mac/drawingml/2011/main" xmlns="" val="0"/>
             </a:ext>
           </a:extLst>
         </p:spPr>
@@ -3820,7 +3828,7 @@
           <a:p>
             <a:pPr algn="l"/>
             <a:fld id="{F7021451-1387-4CA6-816F-3879F97B5CBC}" type="slidenum">
-              <a:rPr b="0" lang="en-US"/>
+              <a:rPr lang="en-US" b="0"/>
               <a:t>10</a:t>
             </a:fld>
             <a:endParaRPr lang="en-US"/>
@@ -3879,7 +3887,7 @@
           <a:bodyPr wrap="square" lIns="254" tIns="254" rIns="254" bIns="254" rtlCol="0" anchor="ctr"/>
           <a:lstStyle/>
           <a:p>
-            <a:pPr algn="ctr" indent="0" marL="0">
+            <a:pPr marL="0" indent="0" algn="ctr">
               <a:buNone/>
             </a:pPr>
             <a:r>
@@ -3918,7 +3926,7 @@
           <a:bodyPr wrap="square" lIns="0" tIns="0" rIns="0" bIns="0" rtlCol="0" anchor="ctr"/>
           <a:lstStyle/>
           <a:p>
-            <a:pPr indent="0" marL="0">
+            <a:pPr marL="0" indent="0">
               <a:buNone/>
             </a:pPr>
             <a:r>
@@ -3959,7 +3967,7 @@
           </a:bodyPr>
           <a:lstStyle/>
           <a:p>
-            <a:pPr indent="0" marL="0">
+            <a:pPr marL="0" indent="0">
               <a:buNone/>
             </a:pPr>
             <a:r>
@@ -4000,7 +4008,7 @@
           </a:bodyPr>
           <a:lstStyle/>
           <a:p>
-            <a:pPr indent="0" marL="0">
+            <a:pPr marL="0" indent="0">
               <a:buNone/>
             </a:pPr>
             <a:r>
@@ -4041,7 +4049,7 @@
             </a:solidFill>
           </a:ln>
           <a:effectLst>
-            <a:outerShdw sx="100000" sy="100000" kx="0" ky="0" algn="bl" rotWithShape="0" blurRad="19050" dist="8890" dir="2700000">
+            <a:outerShdw blurRad="19050" dist="8890" dir="2700000" algn="bl" rotWithShape="0">
               <a:srgbClr val="000000">
                 <a:alpha val="11000"/>
               </a:srgbClr>
@@ -4052,7 +4060,7 @@
           <a:bodyPr wrap="square" lIns="0" tIns="0" rIns="0" bIns="0" rtlCol="0" anchor="ctr"/>
           <a:lstStyle/>
           <a:p>
-            <a:pPr indent="0" marL="0">
+            <a:pPr marL="0" indent="0">
               <a:buNone/>
             </a:pPr>
             <a:endParaRPr lang="en-US" dirty="0"/>
@@ -4080,7 +4088,7 @@
           <a:bodyPr wrap="square" lIns="0" tIns="0" rIns="0" bIns="0" rtlCol="0" anchor="ctr"/>
           <a:lstStyle/>
           <a:p>
-            <a:pPr indent="0" marL="0">
+            <a:pPr marL="0" indent="0">
               <a:buNone/>
             </a:pPr>
             <a:r>
@@ -4220,7 +4228,7 @@
             </a:solidFill>
           </a:ln>
           <a:effectLst>
-            <a:outerShdw sx="100000" sy="100000" kx="0" ky="0" algn="bl" rotWithShape="0" blurRad="19050" dist="8890" dir="2700000">
+            <a:outerShdw blurRad="19050" dist="8890" dir="2700000" algn="bl" rotWithShape="0">
               <a:srgbClr val="000000">
                 <a:alpha val="11000"/>
               </a:srgbClr>
@@ -4231,7 +4239,7 @@
           <a:bodyPr wrap="square" lIns="0" tIns="0" rIns="0" bIns="0" rtlCol="0" anchor="ctr"/>
           <a:lstStyle/>
           <a:p>
-            <a:pPr indent="0" marL="0">
+            <a:pPr marL="0" indent="0">
               <a:buNone/>
             </a:pPr>
             <a:endParaRPr lang="en-US" dirty="0"/>
@@ -4259,7 +4267,7 @@
           <a:bodyPr wrap="square" lIns="0" tIns="0" rIns="0" bIns="0" rtlCol="0" anchor="ctr"/>
           <a:lstStyle/>
           <a:p>
-            <a:pPr indent="0" marL="0">
+            <a:pPr marL="0" indent="0">
               <a:buNone/>
             </a:pPr>
             <a:r>
@@ -4300,7 +4308,7 @@
           </a:bodyPr>
           <a:lstStyle/>
           <a:p>
-            <a:pPr indent="0" marL="0">
+            <a:pPr marL="0" indent="0">
               <a:buNone/>
             </a:pPr>
             <a:r>
@@ -4339,7 +4347,7 @@
           <a:bodyPr wrap="square" lIns="0" tIns="0" rIns="0" bIns="0" rtlCol="0" anchor="ctr"/>
           <a:lstStyle/>
           <a:p>
-            <a:pPr indent="0" marL="0">
+            <a:pPr marL="0" indent="0">
               <a:buNone/>
             </a:pPr>
             <a:r>
@@ -4380,19 +4388,11 @@
           </a:bodyPr>
           <a:lstStyle/>
           <a:p>
-            <a:pPr indent="0" marL="0">
-              <a:buNone/>
-            </a:pPr>
-            <a:r>
-              <a:rPr lang="en-US" sz="1100" dirty="0">
-                <a:solidFill>
-                  <a:srgbClr val="1F2933"/>
-                </a:solidFill>
-                <a:latin typeface="Aptos" pitchFamily="34" charset="0"/>
-                <a:ea typeface="Aptos" pitchFamily="34" charset="-122"/>
-                <a:cs typeface="Aptos" pitchFamily="34" charset="-120"/>
-              </a:rPr>
-              <a:t>Repositorio público, 21/21 tests PASS, deck, guion, matriz ROI, blueprint Databricks y código fuente de respaldo.</a:t>
+            <a:pPr marL="0" indent="0">
+              <a:buNone/>
+            </a:pPr>
+            <a:r>
+              <a:t>Repositorio oficial en GitHub, 23/23 tests PASS, deck, guion, matriz ROI, blueprint Databricks y código fuente de respaldo.</a:t>
             </a:r>
             <a:endParaRPr lang="en-US" sz="1100" dirty="0"/>
           </a:p>
@@ -4419,7 +4419,7 @@
           <a:bodyPr wrap="square" lIns="0" tIns="0" rIns="0" bIns="0" rtlCol="0" anchor="ctr"/>
           <a:lstStyle/>
           <a:p>
-            <a:pPr algn="ctr" indent="0" marL="0">
+            <a:pPr marL="0" indent="0" algn="ctr">
               <a:buNone/>
             </a:pPr>
             <a:r>
@@ -4457,7 +4457,7 @@
           </a:prstGeom>
           <a:extLst>
             <a:ext uri="{C572A759-6A51-4108-AA02-DFA0A04FC94B}">
-              <ma14:wrappingTextBoxFlag xmlns:ma14="http://schemas.microsoft.com/office/mac/drawingml/2011/main" val="0"/>
+              <ma14:wrappingTextBoxFlag xmlns:ma14="http://schemas.microsoft.com/office/mac/drawingml/2011/main" xmlns="" val="0"/>
             </a:ext>
           </a:extLst>
         </p:spPr>
@@ -4475,7 +4475,7 @@
           <a:p>
             <a:pPr algn="l"/>
             <a:fld id="{F7021451-1387-4CA6-816F-3879F97B5CBC}" type="slidenum">
-              <a:rPr b="0" lang="en-US"/>
+              <a:rPr lang="en-US" b="0"/>
               <a:t>11</a:t>
             </a:fld>
             <a:endParaRPr lang="en-US"/>
@@ -4534,7 +4534,7 @@
           <a:bodyPr wrap="square" lIns="254" tIns="254" rIns="254" bIns="254" rtlCol="0" anchor="ctr"/>
           <a:lstStyle/>
           <a:p>
-            <a:pPr algn="ctr" indent="0" marL="0">
+            <a:pPr marL="0" indent="0" algn="ctr">
               <a:buNone/>
             </a:pPr>
             <a:r>
@@ -4573,7 +4573,7 @@
           <a:bodyPr wrap="square" lIns="0" tIns="0" rIns="0" bIns="0" rtlCol="0" anchor="ctr"/>
           <a:lstStyle/>
           <a:p>
-            <a:pPr indent="0" marL="0">
+            <a:pPr marL="0" indent="0">
               <a:buNone/>
             </a:pPr>
             <a:r>
@@ -4614,7 +4614,7 @@
           </a:bodyPr>
           <a:lstStyle/>
           <a:p>
-            <a:pPr indent="0" marL="0">
+            <a:pPr marL="0" indent="0">
               <a:buNone/>
             </a:pPr>
             <a:r>
@@ -4655,7 +4655,7 @@
           </a:bodyPr>
           <a:lstStyle/>
           <a:p>
-            <a:pPr indent="0" marL="0">
+            <a:pPr marL="0" indent="0">
               <a:buNone/>
             </a:pPr>
             <a:r>
@@ -4696,7 +4696,7 @@
             </a:solidFill>
           </a:ln>
           <a:effectLst>
-            <a:outerShdw sx="100000" sy="100000" kx="0" ky="0" algn="bl" rotWithShape="0" blurRad="19050" dist="8890" dir="2700000">
+            <a:outerShdw blurRad="19050" dist="8890" dir="2700000" algn="bl" rotWithShape="0">
               <a:srgbClr val="000000">
                 <a:alpha val="11000"/>
               </a:srgbClr>
@@ -4707,7 +4707,7 @@
           <a:bodyPr wrap="square" lIns="0" tIns="0" rIns="0" bIns="0" rtlCol="0" anchor="ctr"/>
           <a:lstStyle/>
           <a:p>
-            <a:pPr indent="0" marL="0">
+            <a:pPr marL="0" indent="0">
               <a:buNone/>
             </a:pPr>
             <a:endParaRPr lang="en-US" dirty="0"/>
@@ -4716,7 +4716,7 @@
       </p:sp>
       <p:graphicFrame>
         <p:nvGraphicFramePr>
-          <p:cNvPr id="7" name="Chart 0" descr=""/>
+          <p:cNvPr id="7" name="Chart 0"/>
           <p:cNvGraphicFramePr/>
           <p:nvPr/>
         </p:nvGraphicFramePr>
@@ -4724,9 +4724,9 @@
           <a:off x="960120" y="1965960"/>
           <a:ext cx="2423160" cy="2423160"/>
         </p:xfrm>
-        <a:graphic xmlns:a="http://schemas.openxmlformats.org/drawingml/2006/main">
+        <a:graphic>
           <a:graphicData uri="http://schemas.openxmlformats.org/drawingml/2006/chart">
-            <c:chart xmlns:c="http://schemas.openxmlformats.org/drawingml/2006/chart" r:id="rId1"/>
+            <c:chart xmlns:c="http://schemas.openxmlformats.org/drawingml/2006/chart" xmlns:r="http://schemas.openxmlformats.org/officeDocument/2006/relationships" r:id="rId3"/>
           </a:graphicData>
         </a:graphic>
       </p:graphicFrame>
@@ -4753,7 +4753,7 @@
           </a:bodyPr>
           <a:lstStyle/>
           <a:p>
-            <a:pPr algn="ctr" indent="0" marL="0">
+            <a:pPr marL="0" indent="0" algn="ctr">
               <a:buNone/>
             </a:pPr>
             <a:r>
@@ -4794,7 +4794,7 @@
           </a:bodyPr>
           <a:lstStyle/>
           <a:p>
-            <a:pPr algn="ctr" indent="0" marL="0">
+            <a:pPr marL="0" indent="0" algn="ctr">
               <a:buNone/>
             </a:pPr>
             <a:r>
@@ -4811,7 +4811,7 @@
             <a:endParaRPr lang="en-US" sz="880" dirty="0"/>
           </a:p>
           <a:p>
-            <a:pPr algn="ctr" indent="0" marL="0">
+            <a:pPr marL="0" indent="0" algn="ctr">
               <a:buNone/>
             </a:pPr>
             <a:r>
@@ -4852,7 +4852,7 @@
           </a:bodyPr>
           <a:lstStyle/>
           <a:p>
-            <a:pPr algn="ctr" indent="0" marL="0">
+            <a:pPr marL="0" indent="0" algn="ctr">
               <a:buNone/>
             </a:pPr>
             <a:r>
@@ -4893,7 +4893,7 @@
           </a:bodyPr>
           <a:lstStyle/>
           <a:p>
-            <a:pPr algn="ctr" indent="0" marL="0">
+            <a:pPr marL="0" indent="0" algn="ctr">
               <a:buNone/>
             </a:pPr>
             <a:r>
@@ -4910,7 +4910,7 @@
             <a:endParaRPr lang="en-US" sz="880" dirty="0"/>
           </a:p>
           <a:p>
-            <a:pPr algn="ctr" indent="0" marL="0">
+            <a:pPr marL="0" indent="0" algn="ctr">
               <a:buNone/>
             </a:pPr>
             <a:r>
@@ -4951,7 +4951,7 @@
           </a:bodyPr>
           <a:lstStyle/>
           <a:p>
-            <a:pPr algn="ctr" indent="0" marL="0">
+            <a:pPr marL="0" indent="0" algn="ctr">
               <a:buNone/>
             </a:pPr>
             <a:r>
@@ -4992,7 +4992,7 @@
           </a:bodyPr>
           <a:lstStyle/>
           <a:p>
-            <a:pPr algn="ctr" indent="0" marL="0">
+            <a:pPr marL="0" indent="0" algn="ctr">
               <a:buNone/>
             </a:pPr>
             <a:r>
@@ -5009,7 +5009,7 @@
             <a:endParaRPr lang="en-US" sz="880" dirty="0"/>
           </a:p>
           <a:p>
-            <a:pPr algn="ctr" indent="0" marL="0">
+            <a:pPr marL="0" indent="0" algn="ctr">
               <a:buNone/>
             </a:pPr>
             <a:r>
@@ -5050,7 +5050,7 @@
             </a:solidFill>
           </a:ln>
           <a:effectLst>
-            <a:outerShdw sx="100000" sy="100000" kx="0" ky="0" algn="bl" rotWithShape="0" blurRad="19050" dist="8890" dir="2700000">
+            <a:outerShdw blurRad="19050" dist="8890" dir="2700000" algn="bl" rotWithShape="0">
               <a:srgbClr val="000000">
                 <a:alpha val="11000"/>
               </a:srgbClr>
@@ -5061,7 +5061,7 @@
           <a:bodyPr wrap="square" lIns="0" tIns="0" rIns="0" bIns="0" rtlCol="0" anchor="ctr"/>
           <a:lstStyle/>
           <a:p>
-            <a:pPr indent="0" marL="0">
+            <a:pPr marL="0" indent="0">
               <a:buNone/>
             </a:pPr>
             <a:endParaRPr lang="en-US" dirty="0"/>
@@ -5089,7 +5089,7 @@
           <a:bodyPr wrap="square" lIns="0" tIns="0" rIns="0" bIns="0" rtlCol="0" anchor="ctr"/>
           <a:lstStyle/>
           <a:p>
-            <a:pPr indent="0" marL="0">
+            <a:pPr marL="0" indent="0">
               <a:buNone/>
             </a:pPr>
             <a:r>
@@ -5212,7 +5212,7 @@
           <a:bodyPr wrap="square" lIns="0" tIns="0" rIns="0" bIns="0" rtlCol="0" anchor="ctr"/>
           <a:lstStyle/>
           <a:p>
-            <a:pPr indent="0" marL="0">
+            <a:pPr marL="0" indent="0">
               <a:buNone/>
             </a:pPr>
             <a:r>
@@ -5224,7 +5224,7 @@
                 <a:ea typeface="Aptos" pitchFamily="34" charset="-122"/>
                 <a:cs typeface="Aptos" pitchFamily="34" charset="-120"/>
               </a:rPr>
-              <a:t>Mensaje clave para Rafael</a:t>
+              <a:t>Mensaje Clave Estratégico</a:t>
             </a:r>
             <a:endParaRPr lang="en-US" sz="900" dirty="0"/>
           </a:p>
@@ -5253,7 +5253,7 @@
           </a:bodyPr>
           <a:lstStyle/>
           <a:p>
-            <a:pPr indent="0" marL="0">
+            <a:pPr marL="0" indent="0">
               <a:buNone/>
             </a:pPr>
             <a:r>
@@ -5291,7 +5291,7 @@
           </a:prstGeom>
           <a:extLst>
             <a:ext uri="{C572A759-6A51-4108-AA02-DFA0A04FC94B}">
-              <ma14:wrappingTextBoxFlag xmlns:ma14="http://schemas.microsoft.com/office/mac/drawingml/2011/main" val="0"/>
+              <ma14:wrappingTextBoxFlag xmlns:ma14="http://schemas.microsoft.com/office/mac/drawingml/2011/main" xmlns="" val="0"/>
             </a:ext>
           </a:extLst>
         </p:spPr>
@@ -5309,7 +5309,7 @@
           <a:p>
             <a:pPr algn="l"/>
             <a:fld id="{F7021451-1387-4CA6-816F-3879F97B5CBC}" type="slidenum">
-              <a:rPr b="0" lang="en-US"/>
+              <a:rPr lang="en-US" b="0"/>
               <a:t>2</a:t>
             </a:fld>
             <a:endParaRPr lang="en-US"/>
@@ -5368,7 +5368,7 @@
           <a:bodyPr wrap="square" lIns="254" tIns="254" rIns="254" bIns="254" rtlCol="0" anchor="ctr"/>
           <a:lstStyle/>
           <a:p>
-            <a:pPr algn="ctr" indent="0" marL="0">
+            <a:pPr marL="0" indent="0" algn="ctr">
               <a:buNone/>
             </a:pPr>
             <a:r>
@@ -5407,7 +5407,7 @@
           <a:bodyPr wrap="square" lIns="0" tIns="0" rIns="0" bIns="0" rtlCol="0" anchor="ctr"/>
           <a:lstStyle/>
           <a:p>
-            <a:pPr indent="0" marL="0">
+            <a:pPr marL="0" indent="0">
               <a:buNone/>
             </a:pPr>
             <a:r>
@@ -5448,7 +5448,7 @@
           </a:bodyPr>
           <a:lstStyle/>
           <a:p>
-            <a:pPr indent="0" marL="0">
+            <a:pPr marL="0" indent="0">
               <a:buNone/>
             </a:pPr>
             <a:r>
@@ -5489,7 +5489,7 @@
           </a:bodyPr>
           <a:lstStyle/>
           <a:p>
-            <a:pPr indent="0" marL="0">
+            <a:pPr marL="0" indent="0">
               <a:buNone/>
             </a:pPr>
             <a:r>
@@ -5530,7 +5530,7 @@
             </a:solidFill>
           </a:ln>
           <a:effectLst>
-            <a:outerShdw sx="100000" sy="100000" kx="0" ky="0" algn="bl" rotWithShape="0" blurRad="19050" dist="8890" dir="2700000">
+            <a:outerShdw blurRad="19050" dist="8890" dir="2700000" algn="bl" rotWithShape="0">
               <a:srgbClr val="000000">
                 <a:alpha val="11000"/>
               </a:srgbClr>
@@ -5541,7 +5541,7 @@
           <a:bodyPr wrap="square" lIns="0" tIns="0" rIns="0" bIns="0" rtlCol="0" anchor="ctr"/>
           <a:lstStyle/>
           <a:p>
-            <a:pPr indent="0" marL="0">
+            <a:pPr marL="0" indent="0">
               <a:buNone/>
             </a:pPr>
             <a:endParaRPr lang="en-US" dirty="0"/>
@@ -5569,7 +5569,7 @@
           <a:bodyPr wrap="square" lIns="0" tIns="0" rIns="0" bIns="0" rtlCol="0" anchor="ctr"/>
           <a:lstStyle/>
           <a:p>
-            <a:pPr indent="0" marL="0">
+            <a:pPr marL="0" indent="0">
               <a:buNone/>
             </a:pPr>
             <a:r>
@@ -5614,7 +5614,7 @@
           <a:bodyPr wrap="square" lIns="508" tIns="508" rIns="508" bIns="508" rtlCol="0" anchor="ctr"/>
           <a:lstStyle/>
           <a:p>
-            <a:pPr indent="0" marL="0">
+            <a:pPr marL="0" indent="0">
               <a:buNone/>
             </a:pPr>
             <a:r>
@@ -5659,7 +5659,7 @@
           <a:bodyPr wrap="square" lIns="508" tIns="508" rIns="508" bIns="508" rtlCol="0" anchor="ctr"/>
           <a:lstStyle/>
           <a:p>
-            <a:pPr indent="0" marL="0">
+            <a:pPr marL="0" indent="0">
               <a:buNone/>
             </a:pPr>
             <a:r>
@@ -5704,7 +5704,7 @@
           <a:bodyPr wrap="square" lIns="508" tIns="508" rIns="508" bIns="508" rtlCol="0" anchor="ctr"/>
           <a:lstStyle/>
           <a:p>
-            <a:pPr indent="0" marL="0">
+            <a:pPr marL="0" indent="0">
               <a:buNone/>
             </a:pPr>
             <a:r>
@@ -5749,7 +5749,7 @@
           <a:bodyPr wrap="square" lIns="508" tIns="508" rIns="508" bIns="508" rtlCol="0" anchor="ctr"/>
           <a:lstStyle/>
           <a:p>
-            <a:pPr indent="0" marL="0">
+            <a:pPr marL="0" indent="0">
               <a:buNone/>
             </a:pPr>
             <a:r>
@@ -5794,7 +5794,7 @@
           <a:bodyPr wrap="square" lIns="508" tIns="508" rIns="508" bIns="508" rtlCol="0" anchor="ctr"/>
           <a:lstStyle/>
           <a:p>
-            <a:pPr indent="0" marL="0">
+            <a:pPr marL="0" indent="0">
               <a:buNone/>
             </a:pPr>
             <a:r>
@@ -5833,7 +5833,7 @@
           <a:bodyPr wrap="square" lIns="0" tIns="0" rIns="0" bIns="0" rtlCol="0" anchor="ctr"/>
           <a:lstStyle/>
           <a:p>
-            <a:pPr indent="0" marL="0">
+            <a:pPr marL="0" indent="0">
               <a:buNone/>
             </a:pPr>
             <a:r>
@@ -5874,7 +5874,7 @@
           </a:bodyPr>
           <a:lstStyle/>
           <a:p>
-            <a:pPr indent="0" marL="0">
+            <a:pPr marL="0" indent="0">
               <a:buNone/>
             </a:pPr>
             <a:r>
@@ -5891,7 +5891,7 @@
             <a:endParaRPr lang="en-US" sz="1150" dirty="0"/>
           </a:p>
           <a:p>
-            <a:pPr indent="0" marL="0">
+            <a:pPr marL="0" indent="0">
               <a:buNone/>
             </a:pPr>
             <a:r>
@@ -5908,7 +5908,7 @@
             <a:endParaRPr lang="en-US" sz="1150" dirty="0"/>
           </a:p>
           <a:p>
-            <a:pPr indent="0" marL="0">
+            <a:pPr marL="0" indent="0">
               <a:buNone/>
             </a:pPr>
             <a:r>
@@ -5949,7 +5949,7 @@
             </a:solidFill>
           </a:ln>
           <a:effectLst>
-            <a:outerShdw sx="100000" sy="100000" kx="0" ky="0" algn="bl" rotWithShape="0" blurRad="19050" dist="8890" dir="2700000">
+            <a:outerShdw blurRad="19050" dist="8890" dir="2700000" algn="bl" rotWithShape="0">
               <a:srgbClr val="000000">
                 <a:alpha val="11000"/>
               </a:srgbClr>
@@ -5960,7 +5960,7 @@
           <a:bodyPr wrap="square" lIns="0" tIns="0" rIns="0" bIns="0" rtlCol="0" anchor="ctr"/>
           <a:lstStyle/>
           <a:p>
-            <a:pPr indent="0" marL="0">
+            <a:pPr marL="0" indent="0">
               <a:buNone/>
             </a:pPr>
             <a:endParaRPr lang="en-US" dirty="0"/>
@@ -5969,14 +5969,14 @@
       </p:sp>
       <p:pic>
         <p:nvPicPr>
-          <p:cNvPr id="16" name="Image 0" descr="/mnt/data/sol_audit/code/outputs/figures/nlp_cluster3_contrast.png">    </p:cNvPr>
+          <p:cNvPr id="16" name="Image 0" descr="/mnt/data/sol_audit/code/outputs/figures/nlp_cluster3_contrast.png"/>
           <p:cNvPicPr>
             <a:picLocks noChangeAspect="1"/>
           </p:cNvPicPr>
           <p:nvPr/>
         </p:nvPicPr>
         <p:blipFill>
-          <a:blip r:embed="rId1"/>
+          <a:blip r:embed="rId3"/>
           <a:stretch>
             <a:fillRect/>
           </a:stretch>
@@ -6012,7 +6012,7 @@
           <a:bodyPr wrap="square" lIns="0" tIns="0" rIns="0" bIns="0" rtlCol="0" anchor="ctr"/>
           <a:lstStyle/>
           <a:p>
-            <a:pPr indent="0" marL="0">
+            <a:pPr marL="0" indent="0">
               <a:buNone/>
             </a:pPr>
             <a:r>
@@ -6050,7 +6050,7 @@
           </a:prstGeom>
           <a:extLst>
             <a:ext uri="{C572A759-6A51-4108-AA02-DFA0A04FC94B}">
-              <ma14:wrappingTextBoxFlag xmlns:ma14="http://schemas.microsoft.com/office/mac/drawingml/2011/main" val="0"/>
+              <ma14:wrappingTextBoxFlag xmlns:ma14="http://schemas.microsoft.com/office/mac/drawingml/2011/main" xmlns="" val="0"/>
             </a:ext>
           </a:extLst>
         </p:spPr>
@@ -6068,7 +6068,7 @@
           <a:p>
             <a:pPr algn="l"/>
             <a:fld id="{F7021451-1387-4CA6-816F-3879F97B5CBC}" type="slidenum">
-              <a:rPr b="0" lang="en-US"/>
+              <a:rPr lang="en-US" b="0"/>
               <a:t>3</a:t>
             </a:fld>
             <a:endParaRPr lang="en-US"/>
@@ -6127,7 +6127,7 @@
           <a:bodyPr wrap="square" lIns="254" tIns="254" rIns="254" bIns="254" rtlCol="0" anchor="ctr"/>
           <a:lstStyle/>
           <a:p>
-            <a:pPr algn="ctr" indent="0" marL="0">
+            <a:pPr marL="0" indent="0" algn="ctr">
               <a:buNone/>
             </a:pPr>
             <a:r>
@@ -6166,7 +6166,7 @@
           <a:bodyPr wrap="square" lIns="0" tIns="0" rIns="0" bIns="0" rtlCol="0" anchor="ctr"/>
           <a:lstStyle/>
           <a:p>
-            <a:pPr indent="0" marL="0">
+            <a:pPr marL="0" indent="0">
               <a:buNone/>
             </a:pPr>
             <a:r>
@@ -6207,7 +6207,7 @@
           </a:bodyPr>
           <a:lstStyle/>
           <a:p>
-            <a:pPr indent="0" marL="0">
+            <a:pPr marL="0" indent="0">
               <a:buNone/>
             </a:pPr>
             <a:r>
@@ -6248,7 +6248,7 @@
           </a:bodyPr>
           <a:lstStyle/>
           <a:p>
-            <a:pPr indent="0" marL="0">
+            <a:pPr marL="0" indent="0">
               <a:buNone/>
             </a:pPr>
             <a:r>
@@ -6289,7 +6289,7 @@
             </a:solidFill>
           </a:ln>
           <a:effectLst>
-            <a:outerShdw sx="100000" sy="100000" kx="0" ky="0" algn="bl" rotWithShape="0" blurRad="19050" dist="8890" dir="2700000">
+            <a:outerShdw blurRad="19050" dist="8890" dir="2700000" algn="bl" rotWithShape="0">
               <a:srgbClr val="000000">
                 <a:alpha val="11000"/>
               </a:srgbClr>
@@ -6300,7 +6300,7 @@
           <a:bodyPr wrap="square" lIns="0" tIns="0" rIns="0" bIns="0" rtlCol="0" anchor="ctr"/>
           <a:lstStyle/>
           <a:p>
-            <a:pPr indent="0" marL="0">
+            <a:pPr marL="0" indent="0">
               <a:buNone/>
             </a:pPr>
             <a:endParaRPr lang="en-US" dirty="0"/>
@@ -6328,7 +6328,7 @@
           <a:bodyPr wrap="square" lIns="0" tIns="0" rIns="0" bIns="0" rtlCol="0" anchor="ctr"/>
           <a:lstStyle/>
           <a:p>
-            <a:pPr indent="0" marL="0">
+            <a:pPr marL="0" indent="0">
               <a:buNone/>
             </a:pPr>
             <a:r>
@@ -6367,7 +6367,7 @@
           <a:bodyPr wrap="square" lIns="0" tIns="0" rIns="0" bIns="0" rtlCol="0" anchor="ctr"/>
           <a:lstStyle/>
           <a:p>
-            <a:pPr indent="0" marL="0">
+            <a:pPr marL="0" indent="0">
               <a:buNone/>
             </a:pPr>
             <a:r>
@@ -6477,7 +6477,7 @@
         </p:nvSpPr>
         <p:spPr>
           <a:xfrm>
-            <a:off x="914400" y="4462272"/>
+            <a:off x="914400" y="4353985"/>
             <a:ext cx="3657600" cy="256032"/>
           </a:xfrm>
           <a:prstGeom prst="rect">
@@ -6490,7 +6490,7 @@
           <a:bodyPr wrap="square" lIns="0" tIns="0" rIns="0" bIns="0" rtlCol="0" anchor="ctr"/>
           <a:lstStyle/>
           <a:p>
-            <a:pPr indent="0" marL="0">
+            <a:pPr marL="0" indent="0">
               <a:buNone/>
             </a:pPr>
             <a:r>
@@ -6529,7 +6529,7 @@
           <a:bodyPr wrap="square" lIns="0" tIns="0" rIns="0" bIns="0" rtlCol="0" anchor="ctr"/>
           <a:lstStyle/>
           <a:p>
-            <a:pPr indent="0" marL="0">
+            <a:pPr marL="0" indent="0">
               <a:buNone/>
             </a:pPr>
             <a:r>
@@ -6566,7 +6566,7 @@
         </p:spPr>
         <p:txBody>
           <a:bodyPr wrap="square" lIns="635" tIns="635" rIns="635" bIns="635" rtlCol="0" anchor="t">
-            <a:normAutofit/>
+            <a:normAutofit fontScale="85000" lnSpcReduction="20000"/>
           </a:bodyPr>
           <a:lstStyle/>
           <a:p>
@@ -6639,7 +6639,7 @@
             </a:solidFill>
           </a:ln>
           <a:effectLst>
-            <a:outerShdw sx="100000" sy="100000" kx="0" ky="0" algn="bl" rotWithShape="0" blurRad="19050" dist="8890" dir="2700000">
+            <a:outerShdw blurRad="19050" dist="8890" dir="2700000" algn="bl" rotWithShape="0">
               <a:srgbClr val="000000">
                 <a:alpha val="11000"/>
               </a:srgbClr>
@@ -6650,7 +6650,7 @@
           <a:bodyPr wrap="square" lIns="0" tIns="0" rIns="0" bIns="0" rtlCol="0" anchor="ctr"/>
           <a:lstStyle/>
           <a:p>
-            <a:pPr indent="0" marL="0">
+            <a:pPr marL="0" indent="0">
               <a:buNone/>
             </a:pPr>
             <a:endParaRPr lang="en-US" dirty="0"/>
@@ -6678,7 +6678,7 @@
           <a:bodyPr wrap="square" lIns="0" tIns="0" rIns="0" bIns="0" rtlCol="0" anchor="ctr"/>
           <a:lstStyle/>
           <a:p>
-            <a:pPr indent="0" marL="0">
+            <a:pPr marL="0" indent="0">
               <a:buNone/>
             </a:pPr>
             <a:r>
@@ -6719,7 +6719,7 @@
           </a:bodyPr>
           <a:lstStyle/>
           <a:p>
-            <a:pPr algn="ctr" indent="0" marL="0">
+            <a:pPr marL="0" indent="0" algn="ctr">
               <a:buNone/>
             </a:pPr>
             <a:r>
@@ -6760,7 +6760,7 @@
           </a:bodyPr>
           <a:lstStyle/>
           <a:p>
-            <a:pPr algn="ctr" indent="0" marL="0">
+            <a:pPr marL="0" indent="0" algn="ctr">
               <a:buNone/>
             </a:pPr>
             <a:r>
@@ -6777,7 +6777,7 @@
             <a:endParaRPr lang="en-US" sz="880" dirty="0"/>
           </a:p>
           <a:p>
-            <a:pPr algn="ctr" indent="0" marL="0">
+            <a:pPr marL="0" indent="0" algn="ctr">
               <a:buNone/>
             </a:pPr>
             <a:r>
@@ -6818,7 +6818,7 @@
           </a:bodyPr>
           <a:lstStyle/>
           <a:p>
-            <a:pPr algn="ctr" indent="0" marL="0">
+            <a:pPr marL="0" indent="0" algn="ctr">
               <a:buNone/>
             </a:pPr>
             <a:r>
@@ -6859,7 +6859,7 @@
           </a:bodyPr>
           <a:lstStyle/>
           <a:p>
-            <a:pPr algn="ctr" indent="0" marL="0">
+            <a:pPr marL="0" indent="0" algn="ctr">
               <a:buNone/>
             </a:pPr>
             <a:r>
@@ -6876,7 +6876,7 @@
             <a:endParaRPr lang="en-US" sz="880" dirty="0"/>
           </a:p>
           <a:p>
-            <a:pPr algn="ctr" indent="0" marL="0">
+            <a:pPr marL="0" indent="0" algn="ctr">
               <a:buNone/>
             </a:pPr>
             <a:r>
@@ -6917,7 +6917,7 @@
           </a:bodyPr>
           <a:lstStyle/>
           <a:p>
-            <a:pPr algn="ctr" indent="0" marL="0">
+            <a:pPr marL="0" indent="0" algn="ctr">
               <a:buNone/>
             </a:pPr>
             <a:r>
@@ -6958,7 +6958,7 @@
           </a:bodyPr>
           <a:lstStyle/>
           <a:p>
-            <a:pPr algn="ctr" indent="0" marL="0">
+            <a:pPr marL="0" indent="0" algn="ctr">
               <a:buNone/>
             </a:pPr>
             <a:r>
@@ -6975,7 +6975,7 @@
             <a:endParaRPr lang="en-US" sz="880" dirty="0"/>
           </a:p>
           <a:p>
-            <a:pPr algn="ctr" indent="0" marL="0">
+            <a:pPr marL="0" indent="0" algn="ctr">
               <a:buNone/>
             </a:pPr>
             <a:r>
@@ -7014,7 +7014,7 @@
           <a:bodyPr wrap="square" lIns="0" tIns="0" rIns="0" bIns="0" rtlCol="0" anchor="ctr"/>
           <a:lstStyle/>
           <a:p>
-            <a:pPr indent="0" marL="0">
+            <a:pPr marL="0" indent="0">
               <a:buNone/>
             </a:pPr>
             <a:r>
@@ -7121,7 +7121,7 @@
           </a:prstGeom>
           <a:extLst>
             <a:ext uri="{C572A759-6A51-4108-AA02-DFA0A04FC94B}">
-              <ma14:wrappingTextBoxFlag xmlns:ma14="http://schemas.microsoft.com/office/mac/drawingml/2011/main" val="0"/>
+              <ma14:wrappingTextBoxFlag xmlns:ma14="http://schemas.microsoft.com/office/mac/drawingml/2011/main" xmlns="" val="0"/>
             </a:ext>
           </a:extLst>
         </p:spPr>
@@ -7139,7 +7139,7 @@
           <a:p>
             <a:pPr algn="l"/>
             <a:fld id="{F7021451-1387-4CA6-816F-3879F97B5CBC}" type="slidenum">
-              <a:rPr b="0" lang="en-US"/>
+              <a:rPr lang="en-US" b="0"/>
               <a:t>4</a:t>
             </a:fld>
             <a:endParaRPr lang="en-US"/>
@@ -7198,7 +7198,7 @@
           <a:bodyPr wrap="square" lIns="254" tIns="254" rIns="254" bIns="254" rtlCol="0" anchor="ctr"/>
           <a:lstStyle/>
           <a:p>
-            <a:pPr algn="ctr" indent="0" marL="0">
+            <a:pPr marL="0" indent="0" algn="ctr">
               <a:buNone/>
             </a:pPr>
             <a:r>
@@ -7237,7 +7237,7 @@
           <a:bodyPr wrap="square" lIns="0" tIns="0" rIns="0" bIns="0" rtlCol="0" anchor="ctr"/>
           <a:lstStyle/>
           <a:p>
-            <a:pPr indent="0" marL="0">
+            <a:pPr marL="0" indent="0">
               <a:buNone/>
             </a:pPr>
             <a:r>
@@ -7278,7 +7278,7 @@
           </a:bodyPr>
           <a:lstStyle/>
           <a:p>
-            <a:pPr indent="0" marL="0">
+            <a:pPr marL="0" indent="0">
               <a:buNone/>
             </a:pPr>
             <a:r>
@@ -7319,7 +7319,7 @@
           </a:bodyPr>
           <a:lstStyle/>
           <a:p>
-            <a:pPr indent="0" marL="0">
+            <a:pPr marL="0" indent="0">
               <a:buNone/>
             </a:pPr>
             <a:r>
@@ -7360,7 +7360,7 @@
             </a:solidFill>
           </a:ln>
           <a:effectLst>
-            <a:outerShdw sx="100000" sy="100000" kx="0" ky="0" algn="bl" rotWithShape="0" blurRad="19050" dist="8890" dir="2700000">
+            <a:outerShdw blurRad="19050" dist="8890" dir="2700000" algn="bl" rotWithShape="0">
               <a:srgbClr val="000000">
                 <a:alpha val="11000"/>
               </a:srgbClr>
@@ -7371,7 +7371,7 @@
           <a:bodyPr wrap="square" lIns="0" tIns="0" rIns="0" bIns="0" rtlCol="0" anchor="ctr"/>
           <a:lstStyle/>
           <a:p>
-            <a:pPr indent="0" marL="0">
+            <a:pPr marL="0" indent="0">
               <a:buNone/>
             </a:pPr>
             <a:endParaRPr lang="en-US" dirty="0"/>
@@ -7399,7 +7399,7 @@
           <a:bodyPr wrap="square" lIns="0" tIns="0" rIns="0" bIns="0" rtlCol="0" anchor="ctr"/>
           <a:lstStyle/>
           <a:p>
-            <a:pPr indent="0" marL="0">
+            <a:pPr marL="0" indent="0">
               <a:buNone/>
             </a:pPr>
             <a:r>
@@ -7440,7 +7440,7 @@
           <a:bodyPr wrap="square" lIns="635" tIns="635" rIns="635" bIns="635" rtlCol="0" anchor="ctr"/>
           <a:lstStyle/>
           <a:p>
-            <a:pPr indent="0" marL="0">
+            <a:pPr marL="0" indent="0">
               <a:buNone/>
             </a:pPr>
             <a:r>
@@ -7485,7 +7485,7 @@
           <a:bodyPr wrap="square" lIns="635" tIns="635" rIns="635" bIns="635" rtlCol="0" anchor="ctr"/>
           <a:lstStyle/>
           <a:p>
-            <a:pPr indent="0" marL="0">
+            <a:pPr marL="0" indent="0">
               <a:buNone/>
             </a:pPr>
             <a:r>
@@ -7530,7 +7530,7 @@
           <a:bodyPr wrap="square" lIns="635" tIns="635" rIns="635" bIns="635" rtlCol="0" anchor="ctr"/>
           <a:lstStyle/>
           <a:p>
-            <a:pPr indent="0" marL="0">
+            <a:pPr marL="0" indent="0">
               <a:buNone/>
             </a:pPr>
             <a:r>
@@ -7569,7 +7569,7 @@
           <a:bodyPr wrap="square" lIns="0" tIns="0" rIns="0" bIns="0" rtlCol="0" anchor="ctr"/>
           <a:lstStyle/>
           <a:p>
-            <a:pPr indent="0" marL="0">
+            <a:pPr marL="0" indent="0">
               <a:buNone/>
             </a:pPr>
             <a:r>
@@ -7679,7 +7679,7 @@
             </a:solidFill>
           </a:ln>
           <a:effectLst>
-            <a:outerShdw sx="100000" sy="100000" kx="0" ky="0" algn="bl" rotWithShape="0" blurRad="19050" dist="8890" dir="2700000">
+            <a:outerShdw blurRad="19050" dist="8890" dir="2700000" algn="bl" rotWithShape="0">
               <a:srgbClr val="000000">
                 <a:alpha val="11000"/>
               </a:srgbClr>
@@ -7690,7 +7690,7 @@
           <a:bodyPr wrap="square" lIns="0" tIns="0" rIns="0" bIns="0" rtlCol="0" anchor="ctr"/>
           <a:lstStyle/>
           <a:p>
-            <a:pPr indent="0" marL="0">
+            <a:pPr marL="0" indent="0">
               <a:buNone/>
             </a:pPr>
             <a:endParaRPr lang="en-US" dirty="0"/>
@@ -7699,14 +7699,14 @@
       </p:sp>
       <p:pic>
         <p:nvPicPr>
-          <p:cNvPr id="14" name="Image 0" descr="/mnt/data/sol_audit/code/outputs/figures/lift_and_pr_curves.png">    </p:cNvPr>
+          <p:cNvPr id="14" name="Image 0" descr="/mnt/data/sol_audit/code/outputs/figures/lift_and_pr_curves.png"/>
           <p:cNvPicPr>
             <a:picLocks noChangeAspect="1"/>
           </p:cNvPicPr>
           <p:nvPr/>
         </p:nvPicPr>
         <p:blipFill>
-          <a:blip r:embed="rId1"/>
+          <a:blip r:embed="rId3"/>
           <a:stretch>
             <a:fillRect/>
           </a:stretch>
@@ -7742,7 +7742,7 @@
           <a:bodyPr wrap="square" lIns="0" tIns="0" rIns="0" bIns="0" rtlCol="0" anchor="ctr"/>
           <a:lstStyle/>
           <a:p>
-            <a:pPr indent="0" marL="0">
+            <a:pPr marL="0" indent="0">
               <a:buNone/>
             </a:pPr>
             <a:r>
@@ -7780,7 +7780,7 @@
           </a:prstGeom>
           <a:extLst>
             <a:ext uri="{C572A759-6A51-4108-AA02-DFA0A04FC94B}">
-              <ma14:wrappingTextBoxFlag xmlns:ma14="http://schemas.microsoft.com/office/mac/drawingml/2011/main" val="0"/>
+              <ma14:wrappingTextBoxFlag xmlns:ma14="http://schemas.microsoft.com/office/mac/drawingml/2011/main" xmlns="" val="0"/>
             </a:ext>
           </a:extLst>
         </p:spPr>
@@ -7798,7 +7798,7 @@
           <a:p>
             <a:pPr algn="l"/>
             <a:fld id="{F7021451-1387-4CA6-816F-3879F97B5CBC}" type="slidenum">
-              <a:rPr b="0" lang="en-US"/>
+              <a:rPr lang="en-US" b="0"/>
               <a:t>5</a:t>
             </a:fld>
             <a:endParaRPr lang="en-US"/>
@@ -7857,7 +7857,7 @@
           <a:bodyPr wrap="square" lIns="254" tIns="254" rIns="254" bIns="254" rtlCol="0" anchor="ctr"/>
           <a:lstStyle/>
           <a:p>
-            <a:pPr algn="ctr" indent="0" marL="0">
+            <a:pPr marL="0" indent="0" algn="ctr">
               <a:buNone/>
             </a:pPr>
             <a:r>
@@ -7896,7 +7896,7 @@
           <a:bodyPr wrap="square" lIns="0" tIns="0" rIns="0" bIns="0" rtlCol="0" anchor="ctr"/>
           <a:lstStyle/>
           <a:p>
-            <a:pPr indent="0" marL="0">
+            <a:pPr marL="0" indent="0">
               <a:buNone/>
             </a:pPr>
             <a:r>
@@ -7937,7 +7937,7 @@
           </a:bodyPr>
           <a:lstStyle/>
           <a:p>
-            <a:pPr indent="0" marL="0">
+            <a:pPr marL="0" indent="0">
               <a:buNone/>
             </a:pPr>
             <a:r>
@@ -7978,7 +7978,7 @@
           </a:bodyPr>
           <a:lstStyle/>
           <a:p>
-            <a:pPr indent="0" marL="0">
+            <a:pPr marL="0" indent="0">
               <a:buNone/>
             </a:pPr>
             <a:r>
@@ -8019,7 +8019,7 @@
             </a:solidFill>
           </a:ln>
           <a:effectLst>
-            <a:outerShdw sx="100000" sy="100000" kx="0" ky="0" algn="bl" rotWithShape="0" blurRad="19050" dist="8890" dir="2700000">
+            <a:outerShdw blurRad="19050" dist="8890" dir="2700000" algn="bl" rotWithShape="0">
               <a:srgbClr val="000000">
                 <a:alpha val="11000"/>
               </a:srgbClr>
@@ -8030,7 +8030,7 @@
           <a:bodyPr wrap="square" lIns="0" tIns="0" rIns="0" bIns="0" rtlCol="0" anchor="ctr"/>
           <a:lstStyle/>
           <a:p>
-            <a:pPr indent="0" marL="0">
+            <a:pPr marL="0" indent="0">
               <a:buNone/>
             </a:pPr>
             <a:endParaRPr lang="en-US" dirty="0"/>
@@ -8058,7 +8058,7 @@
           <a:bodyPr wrap="square" lIns="0" tIns="0" rIns="0" bIns="0" rtlCol="0" anchor="ctr"/>
           <a:lstStyle/>
           <a:p>
-            <a:pPr indent="0" marL="0">
+            <a:pPr marL="0" indent="0">
               <a:buNone/>
             </a:pPr>
             <a:r>
@@ -8181,7 +8181,7 @@
           <a:bodyPr wrap="square" lIns="0" tIns="0" rIns="0" bIns="0" rtlCol="0" anchor="ctr"/>
           <a:lstStyle/>
           <a:p>
-            <a:pPr indent="0" marL="0">
+            <a:pPr marL="0" indent="0">
               <a:buNone/>
             </a:pPr>
             <a:r>
@@ -8289,7 +8289,7 @@
           <a:bodyPr wrap="square" lIns="0" tIns="0" rIns="0" bIns="0" rtlCol="0" anchor="ctr"/>
           <a:lstStyle/>
           <a:p>
-            <a:pPr indent="0" marL="0">
+            <a:pPr marL="0" indent="0">
               <a:buNone/>
             </a:pPr>
             <a:r>
@@ -8330,7 +8330,7 @@
           </a:bodyPr>
           <a:lstStyle/>
           <a:p>
-            <a:pPr indent="0" marL="0">
+            <a:pPr marL="0" indent="0">
               <a:buNone/>
             </a:pPr>
             <a:r>
@@ -8371,7 +8371,7 @@
             </a:solidFill>
           </a:ln>
           <a:effectLst>
-            <a:outerShdw sx="100000" sy="100000" kx="0" ky="0" algn="bl" rotWithShape="0" blurRad="19050" dist="8890" dir="2700000">
+            <a:outerShdw blurRad="19050" dist="8890" dir="2700000" algn="bl" rotWithShape="0">
               <a:srgbClr val="000000">
                 <a:alpha val="11000"/>
               </a:srgbClr>
@@ -8382,7 +8382,7 @@
           <a:bodyPr wrap="square" lIns="0" tIns="0" rIns="0" bIns="0" rtlCol="0" anchor="ctr"/>
           <a:lstStyle/>
           <a:p>
-            <a:pPr indent="0" marL="0">
+            <a:pPr marL="0" indent="0">
               <a:buNone/>
             </a:pPr>
             <a:endParaRPr lang="en-US" dirty="0"/>
@@ -8391,14 +8391,14 @@
       </p:sp>
       <p:pic>
         <p:nvPicPr>
-          <p:cNvPr id="14" name="Image 0" descr="/mnt/data/sol_audit/code/outputs/figures/shap_beeswarm_model_a.png">    </p:cNvPr>
+          <p:cNvPr id="14" name="Image 0" descr="/mnt/data/sol_audit/code/outputs/figures/shap_beeswarm_model_a.png"/>
           <p:cNvPicPr>
             <a:picLocks noChangeAspect="1"/>
           </p:cNvPicPr>
           <p:nvPr/>
         </p:nvPicPr>
         <p:blipFill>
-          <a:blip r:embed="rId1"/>
+          <a:blip r:embed="rId3"/>
           <a:stretch>
             <a:fillRect/>
           </a:stretch>
@@ -8434,7 +8434,7 @@
           <a:bodyPr wrap="square" lIns="0" tIns="0" rIns="0" bIns="0" rtlCol="0" anchor="ctr"/>
           <a:lstStyle/>
           <a:p>
-            <a:pPr indent="0" marL="0">
+            <a:pPr marL="0" indent="0">
               <a:buNone/>
             </a:pPr>
             <a:r>
@@ -8472,7 +8472,7 @@
           </a:prstGeom>
           <a:extLst>
             <a:ext uri="{C572A759-6A51-4108-AA02-DFA0A04FC94B}">
-              <ma14:wrappingTextBoxFlag xmlns:ma14="http://schemas.microsoft.com/office/mac/drawingml/2011/main" val="0"/>
+              <ma14:wrappingTextBoxFlag xmlns:ma14="http://schemas.microsoft.com/office/mac/drawingml/2011/main" xmlns="" val="0"/>
             </a:ext>
           </a:extLst>
         </p:spPr>
@@ -8490,7 +8490,7 @@
           <a:p>
             <a:pPr algn="l"/>
             <a:fld id="{F7021451-1387-4CA6-816F-3879F97B5CBC}" type="slidenum">
-              <a:rPr b="0" lang="en-US"/>
+              <a:rPr lang="en-US" b="0"/>
               <a:t>6</a:t>
             </a:fld>
             <a:endParaRPr lang="en-US"/>
@@ -8549,7 +8549,7 @@
           <a:bodyPr wrap="square" lIns="254" tIns="254" rIns="254" bIns="254" rtlCol="0" anchor="ctr"/>
           <a:lstStyle/>
           <a:p>
-            <a:pPr algn="ctr" indent="0" marL="0">
+            <a:pPr marL="0" indent="0" algn="ctr">
               <a:buNone/>
             </a:pPr>
             <a:r>
@@ -8588,7 +8588,7 @@
           <a:bodyPr wrap="square" lIns="0" tIns="0" rIns="0" bIns="0" rtlCol="0" anchor="ctr"/>
           <a:lstStyle/>
           <a:p>
-            <a:pPr indent="0" marL="0">
+            <a:pPr marL="0" indent="0">
               <a:buNone/>
             </a:pPr>
             <a:r>
@@ -8629,7 +8629,7 @@
           </a:bodyPr>
           <a:lstStyle/>
           <a:p>
-            <a:pPr indent="0" marL="0">
+            <a:pPr marL="0" indent="0">
               <a:buNone/>
             </a:pPr>
             <a:r>
@@ -8670,7 +8670,7 @@
           </a:bodyPr>
           <a:lstStyle/>
           <a:p>
-            <a:pPr indent="0" marL="0">
+            <a:pPr marL="0" indent="0">
               <a:buNone/>
             </a:pPr>
             <a:r>
@@ -8711,7 +8711,7 @@
             </a:solidFill>
           </a:ln>
           <a:effectLst>
-            <a:outerShdw sx="100000" sy="100000" kx="0" ky="0" algn="bl" rotWithShape="0" blurRad="19050" dist="8890" dir="2700000">
+            <a:outerShdw blurRad="19050" dist="8890" dir="2700000" algn="bl" rotWithShape="0">
               <a:srgbClr val="000000">
                 <a:alpha val="11000"/>
               </a:srgbClr>
@@ -8722,7 +8722,7 @@
           <a:bodyPr wrap="square" lIns="0" tIns="0" rIns="0" bIns="0" rtlCol="0" anchor="ctr"/>
           <a:lstStyle/>
           <a:p>
-            <a:pPr indent="0" marL="0">
+            <a:pPr marL="0" indent="0">
               <a:buNone/>
             </a:pPr>
             <a:endParaRPr lang="en-US" dirty="0"/>
@@ -8752,7 +8752,7 @@
           </a:bodyPr>
           <a:lstStyle/>
           <a:p>
-            <a:pPr indent="0" marL="0">
+            <a:pPr marL="0" indent="0">
               <a:buNone/>
             </a:pPr>
             <a:r>
@@ -8769,7 +8769,7 @@
             <a:endParaRPr lang="en-US" sz="1600" dirty="0"/>
           </a:p>
           <a:p>
-            <a:pPr indent="0" marL="0">
+            <a:pPr marL="0" indent="0">
               <a:buNone/>
             </a:pPr>
             <a:r>
@@ -8810,7 +8810,7 @@
           </a:bodyPr>
           <a:lstStyle/>
           <a:p>
-            <a:pPr indent="0" marL="0">
+            <a:pPr marL="0" indent="0">
               <a:buNone/>
             </a:pPr>
             <a:r>
@@ -8855,7 +8855,7 @@
           <a:bodyPr wrap="square" lIns="254" tIns="254" rIns="254" bIns="254" rtlCol="0" anchor="ctr"/>
           <a:lstStyle/>
           <a:p>
-            <a:pPr algn="ctr" indent="0" marL="0">
+            <a:pPr marL="0" indent="0" algn="ctr">
               <a:buNone/>
             </a:pPr>
             <a:r>
@@ -8896,7 +8896,7 @@
             </a:solidFill>
           </a:ln>
           <a:effectLst>
-            <a:outerShdw sx="100000" sy="100000" kx="0" ky="0" algn="bl" rotWithShape="0" blurRad="19050" dist="8890" dir="2700000">
+            <a:outerShdw blurRad="19050" dist="8890" dir="2700000" algn="bl" rotWithShape="0">
               <a:srgbClr val="000000">
                 <a:alpha val="11000"/>
               </a:srgbClr>
@@ -8907,7 +8907,7 @@
           <a:bodyPr wrap="square" lIns="0" tIns="0" rIns="0" bIns="0" rtlCol="0" anchor="ctr"/>
           <a:lstStyle/>
           <a:p>
-            <a:pPr indent="0" marL="0">
+            <a:pPr marL="0" indent="0">
               <a:buNone/>
             </a:pPr>
             <a:endParaRPr lang="en-US" dirty="0"/>
@@ -8937,7 +8937,7 @@
           </a:bodyPr>
           <a:lstStyle/>
           <a:p>
-            <a:pPr indent="0" marL="0">
+            <a:pPr marL="0" indent="0">
               <a:buNone/>
             </a:pPr>
             <a:r>
@@ -8954,7 +8954,7 @@
             <a:endParaRPr lang="en-US" sz="1600" dirty="0"/>
           </a:p>
           <a:p>
-            <a:pPr indent="0" marL="0">
+            <a:pPr marL="0" indent="0">
               <a:buNone/>
             </a:pPr>
             <a:r>
@@ -8995,7 +8995,7 @@
           </a:bodyPr>
           <a:lstStyle/>
           <a:p>
-            <a:pPr indent="0" marL="0">
+            <a:pPr marL="0" indent="0">
               <a:buNone/>
             </a:pPr>
             <a:r>
@@ -9040,7 +9040,7 @@
           <a:bodyPr wrap="square" lIns="254" tIns="254" rIns="254" bIns="254" rtlCol="0" anchor="ctr"/>
           <a:lstStyle/>
           <a:p>
-            <a:pPr algn="ctr" indent="0" marL="0">
+            <a:pPr marL="0" indent="0" algn="ctr">
               <a:buNone/>
             </a:pPr>
             <a:r>
@@ -9081,7 +9081,7 @@
             </a:solidFill>
           </a:ln>
           <a:effectLst>
-            <a:outerShdw sx="100000" sy="100000" kx="0" ky="0" algn="bl" rotWithShape="0" blurRad="19050" dist="8890" dir="2700000">
+            <a:outerShdw blurRad="19050" dist="8890" dir="2700000" algn="bl" rotWithShape="0">
               <a:srgbClr val="000000">
                 <a:alpha val="11000"/>
               </a:srgbClr>
@@ -9092,7 +9092,7 @@
           <a:bodyPr wrap="square" lIns="0" tIns="0" rIns="0" bIns="0" rtlCol="0" anchor="ctr"/>
           <a:lstStyle/>
           <a:p>
-            <a:pPr indent="0" marL="0">
+            <a:pPr marL="0" indent="0">
               <a:buNone/>
             </a:pPr>
             <a:endParaRPr lang="en-US" dirty="0"/>
@@ -9122,7 +9122,7 @@
           </a:bodyPr>
           <a:lstStyle/>
           <a:p>
-            <a:pPr indent="0" marL="0">
+            <a:pPr marL="0" indent="0">
               <a:buNone/>
             </a:pPr>
             <a:r>
@@ -9139,7 +9139,7 @@
             <a:endParaRPr lang="en-US" sz="1600" dirty="0"/>
           </a:p>
           <a:p>
-            <a:pPr indent="0" marL="0">
+            <a:pPr marL="0" indent="0">
               <a:buNone/>
             </a:pPr>
             <a:r>
@@ -9180,7 +9180,7 @@
           </a:bodyPr>
           <a:lstStyle/>
           <a:p>
-            <a:pPr indent="0" marL="0">
+            <a:pPr marL="0" indent="0">
               <a:buNone/>
             </a:pPr>
             <a:r>
@@ -9225,7 +9225,7 @@
           <a:bodyPr wrap="square" lIns="254" tIns="254" rIns="254" bIns="254" rtlCol="0" anchor="ctr"/>
           <a:lstStyle/>
           <a:p>
-            <a:pPr algn="ctr" indent="0" marL="0">
+            <a:pPr marL="0" indent="0" algn="ctr">
               <a:buNone/>
             </a:pPr>
             <a:r>
@@ -9266,7 +9266,7 @@
             </a:solidFill>
           </a:ln>
           <a:effectLst>
-            <a:outerShdw sx="100000" sy="100000" kx="0" ky="0" algn="bl" rotWithShape="0" blurRad="19050" dist="8890" dir="2700000">
+            <a:outerShdw blurRad="19050" dist="8890" dir="2700000" algn="bl" rotWithShape="0">
               <a:srgbClr val="000000">
                 <a:alpha val="11000"/>
               </a:srgbClr>
@@ -9277,7 +9277,7 @@
           <a:bodyPr wrap="square" lIns="0" tIns="0" rIns="0" bIns="0" rtlCol="0" anchor="ctr"/>
           <a:lstStyle/>
           <a:p>
-            <a:pPr indent="0" marL="0">
+            <a:pPr marL="0" indent="0">
               <a:buNone/>
             </a:pPr>
             <a:endParaRPr lang="en-US" dirty="0"/>
@@ -9307,7 +9307,7 @@
           </a:bodyPr>
           <a:lstStyle/>
           <a:p>
-            <a:pPr indent="0" marL="0">
+            <a:pPr marL="0" indent="0">
               <a:buNone/>
             </a:pPr>
             <a:r>
@@ -9324,7 +9324,7 @@
             <a:endParaRPr lang="en-US" sz="1600" dirty="0"/>
           </a:p>
           <a:p>
-            <a:pPr indent="0" marL="0">
+            <a:pPr marL="0" indent="0">
               <a:buNone/>
             </a:pPr>
             <a:r>
@@ -9365,7 +9365,7 @@
           </a:bodyPr>
           <a:lstStyle/>
           <a:p>
-            <a:pPr indent="0" marL="0">
+            <a:pPr marL="0" indent="0">
               <a:buNone/>
             </a:pPr>
             <a:r>
@@ -9410,7 +9410,7 @@
           <a:bodyPr wrap="square" lIns="254" tIns="254" rIns="254" bIns="254" rtlCol="0" anchor="ctr"/>
           <a:lstStyle/>
           <a:p>
-            <a:pPr algn="ctr" indent="0" marL="0">
+            <a:pPr marL="0" indent="0" algn="ctr">
               <a:buNone/>
             </a:pPr>
             <a:r>
@@ -9451,7 +9451,7 @@
           </a:bodyPr>
           <a:lstStyle/>
           <a:p>
-            <a:pPr algn="ctr" indent="0" marL="0">
+            <a:pPr marL="0" indent="0" algn="ctr">
               <a:buNone/>
             </a:pPr>
             <a:r>
@@ -9490,19 +9490,11 @@
           <a:bodyPr wrap="square" lIns="0" tIns="0" rIns="0" bIns="0" rtlCol="0" anchor="ctr"/>
           <a:lstStyle/>
           <a:p>
-            <a:pPr algn="ctr" indent="0" marL="0">
-              <a:buNone/>
-            </a:pPr>
-            <a:r>
-              <a:rPr lang="en-US" sz="950" b="1" dirty="0">
-                <a:solidFill>
-                  <a:srgbClr val="1E8E3E"/>
-                </a:solidFill>
-                <a:latin typeface="Aptos" pitchFamily="34" charset="0"/>
-                <a:ea typeface="Aptos" pitchFamily="34" charset="-122"/>
-                <a:cs typeface="Aptos" pitchFamily="34" charset="-120"/>
-              </a:rPr>
-              <a:t>18/18 pruebas de Gate 3 + 21/21 suite final PASS</a:t>
+            <a:pPr marL="0" indent="0" algn="ctr">
+              <a:buNone/>
+            </a:pPr>
+            <a:r>
+              <a:t>18/18 pruebas de Gate 3 + 23/23 suite final PASS</a:t>
             </a:r>
             <a:endParaRPr lang="en-US" sz="950" dirty="0"/>
           </a:p>
@@ -9528,7 +9520,7 @@
           </a:prstGeom>
           <a:extLst>
             <a:ext uri="{C572A759-6A51-4108-AA02-DFA0A04FC94B}">
-              <ma14:wrappingTextBoxFlag xmlns:ma14="http://schemas.microsoft.com/office/mac/drawingml/2011/main" val="0"/>
+              <ma14:wrappingTextBoxFlag xmlns:ma14="http://schemas.microsoft.com/office/mac/drawingml/2011/main" xmlns="" val="0"/>
             </a:ext>
           </a:extLst>
         </p:spPr>
@@ -9546,7 +9538,7 @@
           <a:p>
             <a:pPr algn="l"/>
             <a:fld id="{F7021451-1387-4CA6-816F-3879F97B5CBC}" type="slidenum">
-              <a:rPr b="0" lang="en-US"/>
+              <a:rPr lang="en-US" b="0"/>
               <a:t>7</a:t>
             </a:fld>
             <a:endParaRPr lang="en-US"/>
@@ -9605,7 +9597,7 @@
           <a:bodyPr wrap="square" lIns="254" tIns="254" rIns="254" bIns="254" rtlCol="0" anchor="ctr"/>
           <a:lstStyle/>
           <a:p>
-            <a:pPr algn="ctr" indent="0" marL="0">
+            <a:pPr marL="0" indent="0" algn="ctr">
               <a:buNone/>
             </a:pPr>
             <a:r>
@@ -9644,7 +9636,7 @@
           <a:bodyPr wrap="square" lIns="0" tIns="0" rIns="0" bIns="0" rtlCol="0" anchor="ctr"/>
           <a:lstStyle/>
           <a:p>
-            <a:pPr indent="0" marL="0">
+            <a:pPr marL="0" indent="0">
               <a:buNone/>
             </a:pPr>
             <a:r>
@@ -9685,7 +9677,7 @@
           </a:bodyPr>
           <a:lstStyle/>
           <a:p>
-            <a:pPr indent="0" marL="0">
+            <a:pPr marL="0" indent="0">
               <a:buNone/>
             </a:pPr>
             <a:r>
@@ -9726,7 +9718,7 @@
           </a:bodyPr>
           <a:lstStyle/>
           <a:p>
-            <a:pPr indent="0" marL="0">
+            <a:pPr marL="0" indent="0">
               <a:buNone/>
             </a:pPr>
             <a:r>
@@ -9767,7 +9759,7 @@
             </a:solidFill>
           </a:ln>
           <a:effectLst>
-            <a:outerShdw sx="100000" sy="100000" kx="0" ky="0" algn="bl" rotWithShape="0" blurRad="19050" dist="8890" dir="2700000">
+            <a:outerShdw blurRad="19050" dist="8890" dir="2700000" algn="bl" rotWithShape="0">
               <a:srgbClr val="000000">
                 <a:alpha val="11000"/>
               </a:srgbClr>
@@ -9778,7 +9770,7 @@
           <a:bodyPr wrap="square" lIns="0" tIns="0" rIns="0" bIns="0" rtlCol="0" anchor="ctr"/>
           <a:lstStyle/>
           <a:p>
-            <a:pPr indent="0" marL="0">
+            <a:pPr marL="0" indent="0">
               <a:buNone/>
             </a:pPr>
             <a:endParaRPr lang="en-US" dirty="0"/>
@@ -9806,7 +9798,7 @@
           <a:bodyPr wrap="square" lIns="0" tIns="0" rIns="0" bIns="0" rtlCol="0" anchor="ctr"/>
           <a:lstStyle/>
           <a:p>
-            <a:pPr indent="0" marL="0">
+            <a:pPr marL="0" indent="0">
               <a:buNone/>
             </a:pPr>
             <a:r>
@@ -9959,7 +9951,7 @@
           <a:bodyPr wrap="square" lIns="0" tIns="0" rIns="0" bIns="0" rtlCol="0" anchor="ctr"/>
           <a:lstStyle/>
           <a:p>
-            <a:pPr indent="0" marL="0">
+            <a:pPr marL="0" indent="0">
               <a:buNone/>
             </a:pPr>
             <a:r>
@@ -9998,7 +9990,7 @@
           <a:bodyPr wrap="square" lIns="0" tIns="0" rIns="0" bIns="0" rtlCol="0" anchor="ctr"/>
           <a:lstStyle/>
           <a:p>
-            <a:pPr indent="0" marL="0">
+            <a:pPr marL="0" indent="0">
               <a:buNone/>
             </a:pPr>
             <a:r>
@@ -10039,7 +10031,7 @@
             </a:solidFill>
           </a:ln>
           <a:effectLst>
-            <a:outerShdw sx="100000" sy="100000" kx="0" ky="0" algn="bl" rotWithShape="0" blurRad="19050" dist="8890" dir="2700000">
+            <a:outerShdw blurRad="19050" dist="8890" dir="2700000" algn="bl" rotWithShape="0">
               <a:srgbClr val="000000">
                 <a:alpha val="11000"/>
               </a:srgbClr>
@@ -10050,7 +10042,7 @@
           <a:bodyPr wrap="square" lIns="0" tIns="0" rIns="0" bIns="0" rtlCol="0" anchor="ctr"/>
           <a:lstStyle/>
           <a:p>
-            <a:pPr indent="0" marL="0">
+            <a:pPr marL="0" indent="0">
               <a:buNone/>
             </a:pPr>
             <a:endParaRPr lang="en-US" dirty="0"/>
@@ -10078,7 +10070,7 @@
           <a:bodyPr wrap="square" lIns="0" tIns="0" rIns="0" bIns="0" rtlCol="0" anchor="ctr"/>
           <a:lstStyle/>
           <a:p>
-            <a:pPr indent="0" marL="0">
+            <a:pPr marL="0" indent="0">
               <a:buNone/>
             </a:pPr>
             <a:r>
@@ -10119,7 +10111,7 @@
           <a:bodyPr wrap="square" lIns="508" tIns="508" rIns="508" bIns="508" rtlCol="0" anchor="ctr"/>
           <a:lstStyle/>
           <a:p>
-            <a:pPr indent="0" marL="0">
+            <a:pPr marL="0" indent="0">
               <a:buNone/>
             </a:pPr>
             <a:r>
@@ -10166,7 +10158,7 @@
           </a:bodyPr>
           <a:lstStyle/>
           <a:p>
-            <a:pPr indent="0" marL="0">
+            <a:pPr marL="0" indent="0">
               <a:buNone/>
             </a:pPr>
             <a:r>
@@ -10213,7 +10205,7 @@
           </a:bodyPr>
           <a:lstStyle/>
           <a:p>
-            <a:pPr indent="0" marL="0">
+            <a:pPr marL="0" indent="0">
               <a:buNone/>
             </a:pPr>
             <a:r>
@@ -10260,7 +10252,7 @@
           </a:bodyPr>
           <a:lstStyle/>
           <a:p>
-            <a:pPr indent="0" marL="0">
+            <a:pPr marL="0" indent="0">
               <a:buNone/>
             </a:pPr>
             <a:r>
@@ -10307,7 +10299,7 @@
           </a:bodyPr>
           <a:lstStyle/>
           <a:p>
-            <a:pPr indent="0" marL="0">
+            <a:pPr marL="0" indent="0">
               <a:buNone/>
             </a:pPr>
             <a:r>
@@ -10354,7 +10346,7 @@
           </a:bodyPr>
           <a:lstStyle/>
           <a:p>
-            <a:pPr indent="0" marL="0">
+            <a:pPr marL="0" indent="0">
               <a:buNone/>
             </a:pPr>
             <a:r>
@@ -10401,7 +10393,7 @@
           </a:bodyPr>
           <a:lstStyle/>
           <a:p>
-            <a:pPr indent="0" marL="0">
+            <a:pPr marL="0" indent="0">
               <a:buNone/>
             </a:pPr>
             <a:r>
@@ -10442,7 +10434,7 @@
           </a:bodyPr>
           <a:lstStyle/>
           <a:p>
-            <a:pPr indent="0" marL="0">
+            <a:pPr marL="0" indent="0">
               <a:buNone/>
             </a:pPr>
             <a:r>
@@ -10480,7 +10472,7 @@
           </a:prstGeom>
           <a:extLst>
             <a:ext uri="{C572A759-6A51-4108-AA02-DFA0A04FC94B}">
-              <ma14:wrappingTextBoxFlag xmlns:ma14="http://schemas.microsoft.com/office/mac/drawingml/2011/main" val="0"/>
+              <ma14:wrappingTextBoxFlag xmlns:ma14="http://schemas.microsoft.com/office/mac/drawingml/2011/main" xmlns="" val="0"/>
             </a:ext>
           </a:extLst>
         </p:spPr>
@@ -10498,7 +10490,7 @@
           <a:p>
             <a:pPr algn="l"/>
             <a:fld id="{F7021451-1387-4CA6-816F-3879F97B5CBC}" type="slidenum">
-              <a:rPr b="0" lang="en-US"/>
+              <a:rPr lang="en-US" b="0"/>
               <a:t>8</a:t>
             </a:fld>
             <a:endParaRPr lang="en-US"/>
@@ -10557,7 +10549,7 @@
           <a:bodyPr wrap="square" lIns="254" tIns="254" rIns="254" bIns="254" rtlCol="0" anchor="ctr"/>
           <a:lstStyle/>
           <a:p>
-            <a:pPr algn="ctr" indent="0" marL="0">
+            <a:pPr marL="0" indent="0" algn="ctr">
               <a:buNone/>
             </a:pPr>
             <a:r>
@@ -10596,7 +10588,7 @@
           <a:bodyPr wrap="square" lIns="0" tIns="0" rIns="0" bIns="0" rtlCol="0" anchor="ctr"/>
           <a:lstStyle/>
           <a:p>
-            <a:pPr indent="0" marL="0">
+            <a:pPr marL="0" indent="0">
               <a:buNone/>
             </a:pPr>
             <a:r>
@@ -10637,7 +10629,7 @@
           </a:bodyPr>
           <a:lstStyle/>
           <a:p>
-            <a:pPr indent="0" marL="0">
+            <a:pPr marL="0" indent="0">
               <a:buNone/>
             </a:pPr>
             <a:r>
@@ -10678,7 +10670,7 @@
           </a:bodyPr>
           <a:lstStyle/>
           <a:p>
-            <a:pPr indent="0" marL="0">
+            <a:pPr marL="0" indent="0">
               <a:buNone/>
             </a:pPr>
             <a:r>
@@ -10719,7 +10711,7 @@
             </a:solidFill>
           </a:ln>
           <a:effectLst>
-            <a:outerShdw sx="100000" sy="100000" kx="0" ky="0" algn="bl" rotWithShape="0" blurRad="19050" dist="8890" dir="2700000">
+            <a:outerShdw blurRad="19050" dist="8890" dir="2700000" algn="bl" rotWithShape="0">
               <a:srgbClr val="000000">
                 <a:alpha val="11000"/>
               </a:srgbClr>
@@ -10730,7 +10722,7 @@
           <a:bodyPr wrap="square" lIns="0" tIns="0" rIns="0" bIns="0" rtlCol="0" anchor="ctr"/>
           <a:lstStyle/>
           <a:p>
-            <a:pPr indent="0" marL="0">
+            <a:pPr marL="0" indent="0">
               <a:buNone/>
             </a:pPr>
             <a:endParaRPr lang="en-US" dirty="0"/>
@@ -10758,7 +10750,7 @@
           <a:bodyPr wrap="square" lIns="0" tIns="0" rIns="0" bIns="0" rtlCol="0" anchor="ctr"/>
           <a:lstStyle/>
           <a:p>
-            <a:pPr indent="0" marL="0">
+            <a:pPr marL="0" indent="0">
               <a:buNone/>
             </a:pPr>
             <a:r>
@@ -10799,7 +10791,7 @@
           </a:bodyPr>
           <a:lstStyle/>
           <a:p>
-            <a:pPr algn="ctr" indent="0" marL="0">
+            <a:pPr marL="0" indent="0" algn="ctr">
               <a:buNone/>
             </a:pPr>
             <a:r>
@@ -10840,7 +10832,7 @@
           </a:bodyPr>
           <a:lstStyle/>
           <a:p>
-            <a:pPr algn="ctr" indent="0" marL="0">
+            <a:pPr marL="0" indent="0" algn="ctr">
               <a:buNone/>
             </a:pPr>
             <a:r>
@@ -10857,7 +10849,7 @@
             <a:endParaRPr lang="en-US" sz="880" dirty="0"/>
           </a:p>
           <a:p>
-            <a:pPr algn="ctr" indent="0" marL="0">
+            <a:pPr marL="0" indent="0" algn="ctr">
               <a:buNone/>
             </a:pPr>
             <a:r>
@@ -10898,7 +10890,7 @@
           </a:bodyPr>
           <a:lstStyle/>
           <a:p>
-            <a:pPr algn="ctr" indent="0" marL="0">
+            <a:pPr marL="0" indent="0" algn="ctr">
               <a:buNone/>
             </a:pPr>
             <a:r>
@@ -10939,7 +10931,7 @@
           </a:bodyPr>
           <a:lstStyle/>
           <a:p>
-            <a:pPr algn="ctr" indent="0" marL="0">
+            <a:pPr marL="0" indent="0" algn="ctr">
               <a:buNone/>
             </a:pPr>
             <a:r>
@@ -10956,7 +10948,7 @@
             <a:endParaRPr lang="en-US" sz="880" dirty="0"/>
           </a:p>
           <a:p>
-            <a:pPr algn="ctr" indent="0" marL="0">
+            <a:pPr marL="0" indent="0" algn="ctr">
               <a:buNone/>
             </a:pPr>
             <a:r>
@@ -10997,7 +10989,7 @@
           </a:bodyPr>
           <a:lstStyle/>
           <a:p>
-            <a:pPr algn="ctr" indent="0" marL="0">
+            <a:pPr marL="0" indent="0" algn="ctr">
               <a:buNone/>
             </a:pPr>
             <a:r>
@@ -11038,7 +11030,7 @@
           </a:bodyPr>
           <a:lstStyle/>
           <a:p>
-            <a:pPr algn="ctr" indent="0" marL="0">
+            <a:pPr marL="0" indent="0" algn="ctr">
               <a:buNone/>
             </a:pPr>
             <a:r>
@@ -11055,7 +11047,7 @@
             <a:endParaRPr lang="en-US" sz="880" dirty="0"/>
           </a:p>
           <a:p>
-            <a:pPr algn="ctr" indent="0" marL="0">
+            <a:pPr marL="0" indent="0" algn="ctr">
               <a:buNone/>
             </a:pPr>
             <a:r>
@@ -11094,7 +11086,7 @@
           <a:bodyPr wrap="square" lIns="0" tIns="0" rIns="0" bIns="0" rtlCol="0" anchor="ctr"/>
           <a:lstStyle/>
           <a:p>
-            <a:pPr indent="0" marL="0">
+            <a:pPr marL="0" indent="0">
               <a:buNone/>
             </a:pPr>
             <a:r>
@@ -11135,7 +11127,7 @@
           </a:bodyPr>
           <a:lstStyle/>
           <a:p>
-            <a:pPr indent="0" marL="0">
+            <a:pPr marL="0" indent="0">
               <a:buNone/>
             </a:pPr>
             <a:r>
@@ -11174,7 +11166,7 @@
           <a:bodyPr wrap="square" lIns="0" tIns="0" rIns="0" bIns="0" rtlCol="0" anchor="ctr"/>
           <a:lstStyle/>
           <a:p>
-            <a:pPr indent="0" marL="0">
+            <a:pPr marL="0" indent="0">
               <a:buNone/>
             </a:pPr>
             <a:r>
@@ -11215,7 +11207,7 @@
             </a:solidFill>
           </a:ln>
           <a:effectLst>
-            <a:outerShdw sx="100000" sy="100000" kx="0" ky="0" algn="bl" rotWithShape="0" blurRad="19050" dist="8890" dir="2700000">
+            <a:outerShdw blurRad="19050" dist="8890" dir="2700000" algn="bl" rotWithShape="0">
               <a:srgbClr val="000000">
                 <a:alpha val="11000"/>
               </a:srgbClr>
@@ -11226,7 +11218,7 @@
           <a:bodyPr wrap="square" lIns="0" tIns="0" rIns="0" bIns="0" rtlCol="0" anchor="ctr"/>
           <a:lstStyle/>
           <a:p>
-            <a:pPr indent="0" marL="0">
+            <a:pPr marL="0" indent="0">
               <a:buNone/>
             </a:pPr>
             <a:endParaRPr lang="en-US" dirty="0"/>
@@ -11254,7 +11246,7 @@
           <a:bodyPr wrap="square" lIns="0" tIns="0" rIns="0" bIns="0" rtlCol="0" anchor="ctr"/>
           <a:lstStyle/>
           <a:p>
-            <a:pPr indent="0" marL="0">
+            <a:pPr marL="0" indent="0">
               <a:buNone/>
             </a:pPr>
             <a:r>
@@ -11299,7 +11291,7 @@
           <a:bodyPr wrap="square" lIns="635" tIns="635" rIns="635" bIns="635" rtlCol="0" anchor="ctr"/>
           <a:lstStyle/>
           <a:p>
-            <a:pPr indent="0" marL="0">
+            <a:pPr marL="0" indent="0">
               <a:buNone/>
             </a:pPr>
             <a:r>
@@ -11344,7 +11336,7 @@
           <a:bodyPr wrap="square" lIns="635" tIns="635" rIns="635" bIns="635" rtlCol="0" anchor="ctr"/>
           <a:lstStyle/>
           <a:p>
-            <a:pPr indent="0" marL="0">
+            <a:pPr marL="0" indent="0">
               <a:buNone/>
             </a:pPr>
             <a:r>
@@ -11389,7 +11381,7 @@
           <a:bodyPr wrap="square" lIns="635" tIns="635" rIns="635" bIns="635" rtlCol="0" anchor="ctr"/>
           <a:lstStyle/>
           <a:p>
-            <a:pPr indent="0" marL="0">
+            <a:pPr marL="0" indent="0">
               <a:buNone/>
             </a:pPr>
             <a:r>
@@ -11434,7 +11426,7 @@
           <a:bodyPr wrap="square" lIns="635" tIns="635" rIns="635" bIns="635" rtlCol="0" anchor="ctr"/>
           <a:lstStyle/>
           <a:p>
-            <a:pPr indent="0" marL="0">
+            <a:pPr marL="0" indent="0">
               <a:buNone/>
             </a:pPr>
             <a:r>
@@ -11479,7 +11471,7 @@
           <a:bodyPr wrap="square" lIns="635" tIns="635" rIns="635" bIns="635" rtlCol="0" anchor="ctr"/>
           <a:lstStyle/>
           <a:p>
-            <a:pPr indent="0" marL="0">
+            <a:pPr marL="0" indent="0">
               <a:buNone/>
             </a:pPr>
             <a:r>
@@ -11518,7 +11510,7 @@
           <a:bodyPr wrap="square" lIns="0" tIns="0" rIns="0" bIns="0" rtlCol="0" anchor="ctr"/>
           <a:lstStyle/>
           <a:p>
-            <a:pPr indent="0" marL="0">
+            <a:pPr marL="0" indent="0">
               <a:buNone/>
             </a:pPr>
             <a:r>
@@ -11559,7 +11551,7 @@
           </a:bodyPr>
           <a:lstStyle/>
           <a:p>
-            <a:pPr indent="0" marL="0">
+            <a:pPr marL="0" indent="0">
               <a:buNone/>
             </a:pPr>
             <a:r>
@@ -11579,7 +11571,7 @@
       </p:sp>
       <p:sp>
         <p:nvSpPr>
-          <p:cNvPr id="25" name="Slide Number Placeholder 0"/>
+          <p:cNvPr id="26" name="Slide Number Placeholder 0"/>
           <p:cNvSpPr>
             <a:spLocks noGrp="1"/>
           </p:cNvSpPr>
@@ -11597,7 +11589,7 @@
           </a:prstGeom>
           <a:extLst>
             <a:ext uri="{C572A759-6A51-4108-AA02-DFA0A04FC94B}">
-              <ma14:wrappingTextBoxFlag xmlns:ma14="http://schemas.microsoft.com/office/mac/drawingml/2011/main" val="0"/>
+              <ma14:wrappingTextBoxFlag xmlns:ma14="http://schemas.microsoft.com/office/mac/drawingml/2011/main" xmlns="" val="0"/>
             </a:ext>
           </a:extLst>
         </p:spPr>
@@ -11615,7 +11607,7 @@
           <a:p>
             <a:pPr algn="l"/>
             <a:fld id="{F7021451-1387-4CA6-816F-3879F97B5CBC}" type="slidenum">
-              <a:rPr b="0" lang="en-US"/>
+              <a:rPr lang="en-US" b="0"/>
               <a:t>9</a:t>
             </a:fld>
             <a:endParaRPr lang="en-US"/>
@@ -11923,4 +11915,319 @@
     </a:ext>
   </a:extLst>
 </a:theme>
+</file>
+
+<file path=ppt/theme/theme2.xml><?xml version="1.0" encoding="utf-8"?>
+<a:theme xmlns:a="http://schemas.openxmlformats.org/drawingml/2006/main" name="Tema de Office">
+  <a:themeElements>
+    <a:clrScheme name="Office">
+      <a:dk1>
+        <a:sysClr val="windowText" lastClr="000000"/>
+      </a:dk1>
+      <a:lt1>
+        <a:sysClr val="window" lastClr="FFFFFF"/>
+      </a:lt1>
+      <a:dk2>
+        <a:srgbClr val="0E2841"/>
+      </a:dk2>
+      <a:lt2>
+        <a:srgbClr val="E8E8E8"/>
+      </a:lt2>
+      <a:accent1>
+        <a:srgbClr val="156082"/>
+      </a:accent1>
+      <a:accent2>
+        <a:srgbClr val="E97132"/>
+      </a:accent2>
+      <a:accent3>
+        <a:srgbClr val="196B24"/>
+      </a:accent3>
+      <a:accent4>
+        <a:srgbClr val="0F9ED5"/>
+      </a:accent4>
+      <a:accent5>
+        <a:srgbClr val="A02B93"/>
+      </a:accent5>
+      <a:accent6>
+        <a:srgbClr val="4EA72E"/>
+      </a:accent6>
+      <a:hlink>
+        <a:srgbClr val="467886"/>
+      </a:hlink>
+      <a:folHlink>
+        <a:srgbClr val="96607D"/>
+      </a:folHlink>
+    </a:clrScheme>
+    <a:fontScheme name="Office">
+      <a:majorFont>
+        <a:latin typeface="Aptos Display" panose="02110004020202020204"/>
+        <a:ea typeface=""/>
+        <a:cs typeface=""/>
+        <a:font script="Jpan" typeface="游ゴシック Light"/>
+        <a:font script="Hang" typeface="맑은 고딕"/>
+        <a:font script="Hans" typeface="等线 Light"/>
+        <a:font script="Hant" typeface="新細明體"/>
+        <a:font script="Arab" typeface="Times New Roman"/>
+        <a:font script="Hebr" typeface="Times New Roman"/>
+        <a:font script="Thai" typeface="Angsana New"/>
+        <a:font script="Ethi" typeface="Nyala"/>
+        <a:font script="Beng" typeface="Vrinda"/>
+        <a:font script="Gujr" typeface="Shruti"/>
+        <a:font script="Khmr" typeface="MoolBoran"/>
+        <a:font script="Knda" typeface="Tunga"/>
+        <a:font script="Guru" typeface="Raavi"/>
+        <a:font script="Cans" typeface="Euphemia"/>
+        <a:font script="Cher" typeface="Plantagenet Cherokee"/>
+        <a:font script="Yiii" typeface="Microsoft Yi Baiti"/>
+        <a:font script="Tibt" typeface="Microsoft Himalaya"/>
+        <a:font script="Thaa" typeface="MV Boli"/>
+        <a:font script="Deva" typeface="Mangal"/>
+        <a:font script="Telu" typeface="Gautami"/>
+        <a:font script="Taml" typeface="Latha"/>
+        <a:font script="Syrc" typeface="Estrangelo Edessa"/>
+        <a:font script="Orya" typeface="Kalinga"/>
+        <a:font script="Mlym" typeface="Kartika"/>
+        <a:font script="Laoo" typeface="DokChampa"/>
+        <a:font script="Sinh" typeface="Iskoola Pota"/>
+        <a:font script="Mong" typeface="Mongolian Baiti"/>
+        <a:font script="Viet" typeface="Times New Roman"/>
+        <a:font script="Uigh" typeface="Microsoft Uighur"/>
+        <a:font script="Geor" typeface="Sylfaen"/>
+        <a:font script="Armn" typeface="Arial"/>
+        <a:font script="Bugi" typeface="Leelawadee UI"/>
+        <a:font script="Bopo" typeface="Microsoft JhengHei"/>
+        <a:font script="Java" typeface="Javanese Text"/>
+        <a:font script="Lisu" typeface="Segoe UI"/>
+        <a:font script="Mymr" typeface="Myanmar Text"/>
+        <a:font script="Nkoo" typeface="Ebrima"/>
+        <a:font script="Olck" typeface="Nirmala UI"/>
+        <a:font script="Osma" typeface="Ebrima"/>
+        <a:font script="Phag" typeface="Phagspa"/>
+        <a:font script="Syrn" typeface="Estrangelo Edessa"/>
+        <a:font script="Syrj" typeface="Estrangelo Edessa"/>
+        <a:font script="Syre" typeface="Estrangelo Edessa"/>
+        <a:font script="Sora" typeface="Nirmala UI"/>
+        <a:font script="Tale" typeface="Microsoft Tai Le"/>
+        <a:font script="Talu" typeface="Microsoft New Tai Lue"/>
+        <a:font script="Tfng" typeface="Ebrima"/>
+      </a:majorFont>
+      <a:minorFont>
+        <a:latin typeface="Aptos" panose="02110004020202020204"/>
+        <a:ea typeface=""/>
+        <a:cs typeface=""/>
+        <a:font script="Jpan" typeface="游ゴシック"/>
+        <a:font script="Hang" typeface="맑은 고딕"/>
+        <a:font script="Hans" typeface="等线"/>
+        <a:font script="Hant" typeface="新細明體"/>
+        <a:font script="Arab" typeface="Arial"/>
+        <a:font script="Hebr" typeface="Arial"/>
+        <a:font script="Thai" typeface="Cordia New"/>
+        <a:font script="Ethi" typeface="Nyala"/>
+        <a:font script="Beng" typeface="Vrinda"/>
+        <a:font script="Gujr" typeface="Shruti"/>
+        <a:font script="Khmr" typeface="DaunPenh"/>
+        <a:font script="Knda" typeface="Tunga"/>
+        <a:font script="Guru" typeface="Raavi"/>
+        <a:font script="Cans" typeface="Euphemia"/>
+        <a:font script="Cher" typeface="Plantagenet Cherokee"/>
+        <a:font script="Yiii" typeface="Microsoft Yi Baiti"/>
+        <a:font script="Tibt" typeface="Microsoft Himalaya"/>
+        <a:font script="Thaa" typeface="MV Boli"/>
+        <a:font script="Deva" typeface="Mangal"/>
+        <a:font script="Telu" typeface="Gautami"/>
+        <a:font script="Taml" typeface="Latha"/>
+        <a:font script="Syrc" typeface="Estrangelo Edessa"/>
+        <a:font script="Orya" typeface="Kalinga"/>
+        <a:font script="Mlym" typeface="Kartika"/>
+        <a:font script="Laoo" typeface="DokChampa"/>
+        <a:font script="Sinh" typeface="Iskoola Pota"/>
+        <a:font script="Mong" typeface="Mongolian Baiti"/>
+        <a:font script="Viet" typeface="Arial"/>
+        <a:font script="Uigh" typeface="Microsoft Uighur"/>
+        <a:font script="Geor" typeface="Sylfaen"/>
+        <a:font script="Armn" typeface="Arial"/>
+        <a:font script="Bugi" typeface="Leelawadee UI"/>
+        <a:font script="Bopo" typeface="Microsoft JhengHei"/>
+        <a:font script="Java" typeface="Javanese Text"/>
+        <a:font script="Lisu" typeface="Segoe UI"/>
+        <a:font script="Mymr" typeface="Myanmar Text"/>
+        <a:font script="Nkoo" typeface="Ebrima"/>
+        <a:font script="Olck" typeface="Nirmala UI"/>
+        <a:font script="Osma" typeface="Ebrima"/>
+        <a:font script="Phag" typeface="Phagspa"/>
+        <a:font script="Syrn" typeface="Estrangelo Edessa"/>
+        <a:font script="Syrj" typeface="Estrangelo Edessa"/>
+        <a:font script="Syre" typeface="Estrangelo Edessa"/>
+        <a:font script="Sora" typeface="Nirmala UI"/>
+        <a:font script="Tale" typeface="Microsoft Tai Le"/>
+        <a:font script="Talu" typeface="Microsoft New Tai Lue"/>
+        <a:font script="Tfng" typeface="Ebrima"/>
+      </a:minorFont>
+    </a:fontScheme>
+    <a:fmtScheme name="Office">
+      <a:fillStyleLst>
+        <a:solidFill>
+          <a:schemeClr val="phClr"/>
+        </a:solidFill>
+        <a:gradFill rotWithShape="1">
+          <a:gsLst>
+            <a:gs pos="0">
+              <a:schemeClr val="phClr">
+                <a:lumMod val="110000"/>
+                <a:satMod val="105000"/>
+                <a:tint val="67000"/>
+              </a:schemeClr>
+            </a:gs>
+            <a:gs pos="50000">
+              <a:schemeClr val="phClr">
+                <a:lumMod val="105000"/>
+                <a:satMod val="103000"/>
+                <a:tint val="73000"/>
+              </a:schemeClr>
+            </a:gs>
+            <a:gs pos="100000">
+              <a:schemeClr val="phClr">
+                <a:lumMod val="105000"/>
+                <a:satMod val="109000"/>
+                <a:tint val="81000"/>
+              </a:schemeClr>
+            </a:gs>
+          </a:gsLst>
+          <a:lin ang="5400000" scaled="0"/>
+        </a:gradFill>
+        <a:gradFill rotWithShape="1">
+          <a:gsLst>
+            <a:gs pos="0">
+              <a:schemeClr val="phClr">
+                <a:satMod val="103000"/>
+                <a:lumMod val="102000"/>
+                <a:tint val="94000"/>
+              </a:schemeClr>
+            </a:gs>
+            <a:gs pos="50000">
+              <a:schemeClr val="phClr">
+                <a:satMod val="110000"/>
+                <a:lumMod val="100000"/>
+                <a:shade val="100000"/>
+              </a:schemeClr>
+            </a:gs>
+            <a:gs pos="100000">
+              <a:schemeClr val="phClr">
+                <a:lumMod val="99000"/>
+                <a:satMod val="120000"/>
+                <a:shade val="78000"/>
+              </a:schemeClr>
+            </a:gs>
+          </a:gsLst>
+          <a:lin ang="5400000" scaled="0"/>
+        </a:gradFill>
+      </a:fillStyleLst>
+      <a:lnStyleLst>
+        <a:ln w="12700" cap="flat" cmpd="sng" algn="ctr">
+          <a:solidFill>
+            <a:schemeClr val="phClr"/>
+          </a:solidFill>
+          <a:prstDash val="solid"/>
+          <a:miter lim="800000"/>
+        </a:ln>
+        <a:ln w="19050" cap="flat" cmpd="sng" algn="ctr">
+          <a:solidFill>
+            <a:schemeClr val="phClr"/>
+          </a:solidFill>
+          <a:prstDash val="solid"/>
+          <a:miter lim="800000"/>
+        </a:ln>
+        <a:ln w="25400" cap="flat" cmpd="sng" algn="ctr">
+          <a:solidFill>
+            <a:schemeClr val="phClr"/>
+          </a:solidFill>
+          <a:prstDash val="solid"/>
+          <a:miter lim="800000"/>
+        </a:ln>
+      </a:lnStyleLst>
+      <a:effectStyleLst>
+        <a:effectStyle>
+          <a:effectLst/>
+        </a:effectStyle>
+        <a:effectStyle>
+          <a:effectLst/>
+        </a:effectStyle>
+        <a:effectStyle>
+          <a:effectLst>
+            <a:outerShdw blurRad="57150" dist="19050" dir="5400000" algn="ctr" rotWithShape="0">
+              <a:srgbClr val="000000">
+                <a:alpha val="63000"/>
+              </a:srgbClr>
+            </a:outerShdw>
+          </a:effectLst>
+        </a:effectStyle>
+      </a:effectStyleLst>
+      <a:bgFillStyleLst>
+        <a:solidFill>
+          <a:schemeClr val="phClr"/>
+        </a:solidFill>
+        <a:solidFill>
+          <a:schemeClr val="phClr">
+            <a:tint val="95000"/>
+            <a:satMod val="170000"/>
+          </a:schemeClr>
+        </a:solidFill>
+        <a:gradFill rotWithShape="1">
+          <a:gsLst>
+            <a:gs pos="0">
+              <a:schemeClr val="phClr">
+                <a:tint val="93000"/>
+                <a:satMod val="150000"/>
+                <a:shade val="98000"/>
+                <a:lumMod val="102000"/>
+              </a:schemeClr>
+            </a:gs>
+            <a:gs pos="50000">
+              <a:schemeClr val="phClr">
+                <a:tint val="98000"/>
+                <a:satMod val="130000"/>
+                <a:shade val="90000"/>
+                <a:lumMod val="103000"/>
+              </a:schemeClr>
+            </a:gs>
+            <a:gs pos="100000">
+              <a:schemeClr val="phClr">
+                <a:shade val="63000"/>
+                <a:satMod val="120000"/>
+              </a:schemeClr>
+            </a:gs>
+          </a:gsLst>
+          <a:lin ang="5400000" scaled="0"/>
+        </a:gradFill>
+      </a:bgFillStyleLst>
+    </a:fmtScheme>
+  </a:themeElements>
+  <a:objectDefaults>
+    <a:lnDef>
+      <a:spPr/>
+      <a:bodyPr/>
+      <a:lstStyle/>
+      <a:style>
+        <a:lnRef idx="2">
+          <a:schemeClr val="accent1"/>
+        </a:lnRef>
+        <a:fillRef idx="0">
+          <a:schemeClr val="accent1"/>
+        </a:fillRef>
+        <a:effectRef idx="1">
+          <a:schemeClr val="accent1"/>
+        </a:effectRef>
+        <a:fontRef idx="minor">
+          <a:schemeClr val="tx1"/>
+        </a:fontRef>
+      </a:style>
+    </a:lnDef>
+  </a:objectDefaults>
+  <a:extraClrSchemeLst/>
+  <a:extLst>
+    <a:ext uri="{05A4C25C-085E-4340-85A3-A5531E510DB2}">
+      <thm15:themeFamily xmlns:thm15="http://schemas.microsoft.com/office/thememl/2012/main" name="Office Theme" id="{2E142A2C-CD16-42D6-873A-C26D2A0506FA}" vid="{1BDDFF52-6CD6-40A5-AB3C-68EB2F1E4D0A}"/>
+    </a:ext>
+  </a:extLst>
+</a:theme>
 </file>
</xml_diff>